<commit_message>
Fix inaccuracies in docs and presentation
- MVP report: Logistic Regression marked as best (AUC 0.9913), not XGBoost; sensitivity scenarios fixed to 5
- Final report: dataset fields updated 31 → 33
- Presentation slide 4: removed 2 non-engineered features from Feature Engineering list
- Presentation demo slide: 15+ → 13 inputs, 6 → 5 sensitivity scenarios
</commit_message>
<xml_diff>
--- a/presentation/final_presentation.pptx
+++ b/presentation/final_presentation.pptx
@@ -4486,6 +4486,10 @@
           </a:solidFill>
           <a:ln/>
         </p:spPr>
+        <p:txBody>
+          <a:bodyPr/>
+          <a:p/>
+        </p:txBody>
       </p:sp>
       <p:sp>
         <p:nvSpPr>
@@ -4584,6 +4588,10 @@
           </a:solidFill>
           <a:ln/>
         </p:spPr>
+        <p:txBody>
+          <a:bodyPr/>
+          <a:p/>
+        </p:txBody>
       </p:sp>
       <p:sp>
         <p:nvSpPr>
@@ -4643,6 +4651,10 @@
           </a:solidFill>
           <a:ln/>
         </p:spPr>
+        <p:txBody>
+          <a:bodyPr/>
+          <a:p/>
+        </p:txBody>
       </p:sp>
       <p:sp>
         <p:nvSpPr>
@@ -4702,6 +4714,10 @@
           </a:solidFill>
           <a:ln/>
         </p:spPr>
+        <p:txBody>
+          <a:bodyPr/>
+          <a:p/>
+        </p:txBody>
       </p:sp>
       <p:sp>
         <p:nvSpPr>
@@ -4761,6 +4777,10 @@
           </a:solidFill>
           <a:ln/>
         </p:spPr>
+        <p:txBody>
+          <a:bodyPr/>
+          <a:p/>
+        </p:txBody>
       </p:sp>
       <p:sp>
         <p:nvSpPr>
@@ -4820,6 +4840,10 @@
           </a:solidFill>
           <a:ln/>
         </p:spPr>
+        <p:txBody>
+          <a:bodyPr/>
+          <a:p/>
+        </p:txBody>
       </p:sp>
       <p:sp>
         <p:nvSpPr>
@@ -4923,6 +4947,10 @@
             <a:prstDash val="solid"/>
           </a:ln>
         </p:spPr>
+        <p:txBody>
+          <a:bodyPr/>
+          <a:p/>
+        </p:txBody>
       </p:sp>
       <p:sp>
         <p:nvSpPr>
@@ -5026,6 +5054,10 @@
             <a:prstDash val="solid"/>
           </a:ln>
         </p:spPr>
+        <p:txBody>
+          <a:bodyPr/>
+          <a:p/>
+        </p:txBody>
       </p:sp>
       <p:sp>
         <p:nvSpPr>
@@ -5129,6 +5161,10 @@
             <a:prstDash val="solid"/>
           </a:ln>
         </p:spPr>
+        <p:txBody>
+          <a:bodyPr/>
+          <a:p/>
+        </p:txBody>
       </p:sp>
       <p:sp>
         <p:nvSpPr>
@@ -5232,6 +5268,10 @@
             <a:prstDash val="solid"/>
           </a:ln>
         </p:spPr>
+        <p:txBody>
+          <a:bodyPr/>
+          <a:p/>
+        </p:txBody>
       </p:sp>
       <p:sp>
         <p:nvSpPr>
@@ -5335,6 +5375,10 @@
             <a:prstDash val="solid"/>
           </a:ln>
         </p:spPr>
+        <p:txBody>
+          <a:bodyPr/>
+          <a:p/>
+        </p:txBody>
       </p:sp>
       <p:sp>
         <p:nvSpPr>
@@ -5438,6 +5482,10 @@
             <a:prstDash val="solid"/>
           </a:ln>
         </p:spPr>
+        <p:txBody>
+          <a:bodyPr/>
+          <a:p/>
+        </p:txBody>
       </p:sp>
       <p:sp>
         <p:nvSpPr>
@@ -5541,6 +5589,10 @@
             <a:prstDash val="solid"/>
           </a:ln>
         </p:spPr>
+        <p:txBody>
+          <a:bodyPr/>
+          <a:p/>
+        </p:txBody>
       </p:sp>
       <p:sp>
         <p:nvSpPr>
@@ -5575,7 +5627,7 @@
                 <a:ea typeface="Calibri" pitchFamily="34" charset="-122"/>
                 <a:cs typeface="Calibri" pitchFamily="34" charset="-120"/>
               </a:rPr>
-              <a:t>עלות למ² בנייה</a:t>
+              <a:t/>
             </a:r>
             <a:endParaRPr lang="en-US" sz="1100" dirty="0"/>
           </a:p>
@@ -5614,7 +5666,7 @@
                 <a:ea typeface="Calibri" pitchFamily="34" charset="-122"/>
                 <a:cs typeface="Calibri" pitchFamily="34" charset="-120"/>
               </a:rPr>
-              <a:t>cost_per_sqm (₪/m²)</a:t>
+              <a:t/>
             </a:r>
             <a:endParaRPr lang="en-US" sz="950" dirty="0"/>
           </a:p>
@@ -5644,6 +5696,10 @@
             <a:prstDash val="solid"/>
           </a:ln>
         </p:spPr>
+        <p:txBody>
+          <a:bodyPr/>
+          <a:p/>
+        </p:txBody>
       </p:sp>
       <p:sp>
         <p:nvSpPr>
@@ -5678,7 +5734,7 @@
                 <a:ea typeface="Calibri" pitchFamily="34" charset="-122"/>
                 <a:cs typeface="Calibri" pitchFamily="34" charset="-120"/>
               </a:rPr>
-              <a:t>חודשי החתמה</a:t>
+              <a:t/>
             </a:r>
             <a:endParaRPr lang="en-US" sz="1100" dirty="0"/>
           </a:p>
@@ -5717,7 +5773,7 @@
                 <a:ea typeface="Calibri" pitchFamily="34" charset="-122"/>
                 <a:cs typeface="Calibri" pitchFamily="34" charset="-120"/>
               </a:rPr>
-              <a:t>signing_months</a:t>
+              <a:t/>
             </a:r>
             <a:endParaRPr lang="en-US" sz="950" dirty="0"/>
           </a:p>
@@ -5745,6 +5801,10 @@
             <a:prstDash val="solid"/>
           </a:ln>
         </p:spPr>
+        <p:txBody>
+          <a:bodyPr/>
+          <a:p/>
+        </p:txBody>
       </p:sp>
       <p:sp>
         <p:nvSpPr>
@@ -8799,6 +8859,10 @@
           </a:solidFill>
           <a:ln/>
         </p:spPr>
+        <p:txBody>
+          <a:bodyPr/>
+          <a:p/>
+        </p:txBody>
       </p:sp>
       <p:sp>
         <p:nvSpPr>
@@ -8998,7 +9062,7 @@
                 <a:ea typeface="Calibri" pitchFamily="34" charset="-122"/>
                 <a:cs typeface="Calibri" pitchFamily="34" charset="-120"/>
               </a:rPr>
-              <a:t>• sidebar קלט עם 15+ פרמטרים</a:t>
+              <a:t>• sidebar קלט עם 13 פרמטרים</a:t>
             </a:r>
             <a:endParaRPr lang="en-US" sz="1200" dirty="0"/>
           </a:p>
@@ -9115,7 +9179,7 @@
                 <a:ea typeface="Calibri" pitchFamily="34" charset="-122"/>
                 <a:cs typeface="Calibri" pitchFamily="34" charset="-120"/>
               </a:rPr>
-              <a:t>• טבלת רגישות 6 תרחישים אוטומטיים</a:t>
+              <a:t>• טבלת רגישות 5 תרחישים אוטומטיים</a:t>
             </a:r>
             <a:endParaRPr lang="en-US" sz="1200" dirty="0"/>
           </a:p>

</xml_diff>

<commit_message>
Fix reversed Hebrew RTL text in charts 02, 03, 05
Added python-bidi fix_heb() helper to eda_and_eval.py:
- Chart 02: city names on Y-axis now display correctly RTL
- Chart 03: correlation heatmap Hebrew feature names now correct
- Chart 05: project type names on X-axis now display correctly RTL

Regenerated 3 PNG figures and updated embedded image in PPTX Slide 6.
</commit_message>
<xml_diff>
--- a/presentation/final_presentation.pptx
+++ b/presentation/final_presentation.pptx
@@ -4,6 +4,9 @@
   <p:sldMasterIdLst>
     <p:sldMasterId id="2147483648" r:id="rId1"/>
   </p:sldMasterIdLst>
+  <p:notesMasterIdLst>
+    <p:notesMasterId r:id="rId10"/>
+  </p:notesMasterIdLst>
   <p:sldIdLst>
     <p:sldId id="256" r:id="rId2"/>
     <p:sldId id="257" r:id="rId3"/>
@@ -14,10 +17,7 @@
     <p:sldId id="262" r:id="rId8"/>
     <p:sldId id="263" r:id="rId9"/>
   </p:sldIdLst>
-  <p:notesMasterIdLst>
-    <p:notesMasterId r:id="rId10"/>
-  </p:notesMasterIdLst>
-  <p:sldSz cx="9144000" cy="5143500"/>
+  <p:sldSz cx="9144000" cy="5143500" type="screen16x9"/>
   <p:notesSz cx="5143500" cy="9144000"/>
   <p:defaultTextStyle>
     <a:lvl1pPr marL="0" algn="l" defTabSz="914400" rtl="0" eaLnBrk="1" latinLnBrk="0" hangingPunct="1">
@@ -111,6 +111,11 @@
       </a:defRPr>
     </a:lvl9pPr>
   </p:defaultTextStyle>
+  <p:extLst>
+    <p:ext uri="{EFAFB233-063F-42B5-8137-9DF3F51BA10A}">
+      <p15:sldGuideLst xmlns:p15="http://schemas.microsoft.com/office/powerpoint/2012/main"/>
+    </p:ext>
+  </p:extLst>
 </p:presentation>
 </file>
 
@@ -136,240 +141,16 @@
           <a:chExt cx="0" cy="0"/>
         </a:xfrm>
       </p:grpSpPr>
-      <p:sp>
-        <p:nvSpPr>
-          <p:cNvPr id="2" name="Header Placeholder 1"/>
-          <p:cNvSpPr>
-            <a:spLocks noGrp="1"/>
-          </p:cNvSpPr>
-          <p:nvPr>
-            <p:ph type="hdr" sz="quarter"/>
-          </p:nvPr>
-        </p:nvSpPr>
-        <p:spPr>
-          <a:xfrm>
-            <a:off x="0" y="0"/>
-            <a:ext cx="2971800" cy="458788"/>
-          </a:xfrm>
-          <a:prstGeom prst="rect">
-            <a:avLst/>
-          </a:prstGeom>
-        </p:spPr>
-        <p:txBody>
-          <a:bodyPr vert="horz" lIns="91440" tIns="45720" rIns="91440" bIns="45720" rtlCol="0"/>
-          <a:lstStyle>
-            <a:lvl1pPr algn="l">
-              <a:defRPr sz="1200"/>
-            </a:lvl1pPr>
-          </a:lstStyle>
-          <a:p>
-            <a:endParaRPr lang="en-US"/>
-          </a:p>
-        </p:txBody>
-      </p:sp>
-      <p:sp>
-        <p:nvSpPr>
-          <p:cNvPr id="3" name="Date Placeholder 2"/>
-          <p:cNvSpPr>
-            <a:spLocks noGrp="1"/>
-          </p:cNvSpPr>
-          <p:nvPr>
-            <p:ph type="dt" idx="1"/>
-          </p:nvPr>
-        </p:nvSpPr>
-        <p:spPr>
-          <a:xfrm>
-            <a:off x="3884613" y="0"/>
-            <a:ext cx="2971800" cy="458788"/>
-          </a:xfrm>
-          <a:prstGeom prst="rect">
-            <a:avLst/>
-          </a:prstGeom>
-        </p:spPr>
-        <p:txBody>
-          <a:bodyPr vert="horz" lIns="91440" tIns="45720" rIns="91440" bIns="45720" rtlCol="0"/>
-          <a:lstStyle>
-            <a:lvl1pPr algn="r">
-              <a:defRPr sz="1200"/>
-            </a:lvl1pPr>
-          </a:lstStyle>
-          <a:p>
-            <a:fld id="{5282F153-3F37-0F45-9E97-73ACFA13230C}" type="datetimeFigureOut">
-              <a:rPr lang="en-US"/>
-              <a:t>7/23/19</a:t>
-            </a:fld>
-            <a:endParaRPr lang="en-US"/>
-          </a:p>
-        </p:txBody>
-      </p:sp>
-      <p:sp>
-        <p:nvSpPr>
-          <p:cNvPr id="4" name="Slide Image Placeholder 3"/>
-          <p:cNvSpPr>
-            <a:spLocks noGrp="1" noRot="1" noChangeAspect="1"/>
-          </p:cNvSpPr>
-          <p:nvPr>
-            <p:ph type="sldImg" idx="2"/>
-          </p:nvPr>
-        </p:nvSpPr>
-        <p:spPr>
-          <a:xfrm>
-            <a:off x="685800" y="1143000"/>
-            <a:ext cx="5486400" cy="3086100"/>
-          </a:xfrm>
-          <a:prstGeom prst="rect">
-            <a:avLst/>
-          </a:prstGeom>
-          <a:noFill/>
-          <a:ln w="12700">
-            <a:solidFill>
-              <a:prstClr val="black"/>
-            </a:solidFill>
-          </a:ln>
-        </p:spPr>
-        <p:txBody>
-          <a:bodyPr vert="horz" lIns="91440" tIns="45720" rIns="91440" bIns="45720" rtlCol="0" anchor="ctr"/>
-          <a:lstStyle/>
-          <a:p>
-            <a:endParaRPr lang="en-US"/>
-          </a:p>
-        </p:txBody>
-      </p:sp>
-      <p:sp>
-        <p:nvSpPr>
-          <p:cNvPr id="5" name="Notes Placeholder 4"/>
-          <p:cNvSpPr>
-            <a:spLocks noGrp="1"/>
-          </p:cNvSpPr>
-          <p:nvPr>
-            <p:ph type="body" sz="quarter" idx="3"/>
-          </p:nvPr>
-        </p:nvSpPr>
-        <p:spPr>
-          <a:xfrm>
-            <a:off x="685800" y="4400550"/>
-            <a:ext cx="5486400" cy="3600450"/>
-          </a:xfrm>
-          <a:prstGeom prst="rect">
-            <a:avLst/>
-          </a:prstGeom>
-        </p:spPr>
-        <p:txBody>
-          <a:bodyPr vert="horz" lIns="91440" tIns="45720" rIns="91440" bIns="45720" rtlCol="0"/>
-          <a:lstStyle/>
-          <a:p>
-            <a:pPr lvl="0"/>
-            <a:r>
-              <a:rPr lang="en-US"/>
-              <a:t>Click to edit Master text styles</a:t>
-            </a:r>
-          </a:p>
-          <a:p>
-            <a:pPr lvl="1"/>
-            <a:r>
-              <a:rPr lang="en-US"/>
-              <a:t>Second level</a:t>
-            </a:r>
-          </a:p>
-          <a:p>
-            <a:pPr lvl="2"/>
-            <a:r>
-              <a:rPr lang="en-US"/>
-              <a:t>Third level</a:t>
-            </a:r>
-          </a:p>
-          <a:p>
-            <a:pPr lvl="3"/>
-            <a:r>
-              <a:rPr lang="en-US"/>
-              <a:t>Fourth level</a:t>
-            </a:r>
-          </a:p>
-          <a:p>
-            <a:pPr lvl="4"/>
-            <a:r>
-              <a:rPr lang="en-US"/>
-              <a:t>Fifth level</a:t>
-            </a:r>
-          </a:p>
-        </p:txBody>
-      </p:sp>
-      <p:sp>
-        <p:nvSpPr>
-          <p:cNvPr id="6" name="Footer Placeholder 5"/>
-          <p:cNvSpPr>
-            <a:spLocks noGrp="1"/>
-          </p:cNvSpPr>
-          <p:nvPr>
-            <p:ph type="ftr" sz="quarter" idx="4"/>
-          </p:nvPr>
-        </p:nvSpPr>
-        <p:spPr>
-          <a:xfrm>
-            <a:off x="0" y="8685213"/>
-            <a:ext cx="2971800" cy="458787"/>
-          </a:xfrm>
-          <a:prstGeom prst="rect">
-            <a:avLst/>
-          </a:prstGeom>
-        </p:spPr>
-        <p:txBody>
-          <a:bodyPr vert="horz" lIns="91440" tIns="45720" rIns="91440" bIns="45720" rtlCol="0" anchor="b"/>
-          <a:lstStyle>
-            <a:lvl1pPr algn="l">
-              <a:defRPr sz="1200"/>
-            </a:lvl1pPr>
-          </a:lstStyle>
-          <a:p>
-            <a:endParaRPr lang="en-US"/>
-          </a:p>
-        </p:txBody>
-      </p:sp>
-      <p:sp>
-        <p:nvSpPr>
-          <p:cNvPr id="7" name="Slide Number Placeholder 6"/>
-          <p:cNvSpPr>
-            <a:spLocks noGrp="1"/>
-          </p:cNvSpPr>
-          <p:nvPr>
-            <p:ph type="sldNum" sz="quarter" idx="5"/>
-          </p:nvPr>
-        </p:nvSpPr>
-        <p:spPr>
-          <a:xfrm>
-            <a:off x="3884613" y="8685213"/>
-            <a:ext cx="2971800" cy="458787"/>
-          </a:xfrm>
-          <a:prstGeom prst="rect">
-            <a:avLst/>
-          </a:prstGeom>
-        </p:spPr>
-        <p:txBody>
-          <a:bodyPr vert="horz" lIns="91440" tIns="45720" rIns="91440" bIns="45720" rtlCol="0" anchor="b"/>
-          <a:lstStyle>
-            <a:lvl1pPr algn="r">
-              <a:defRPr sz="1200"/>
-            </a:lvl1pPr>
-          </a:lstStyle>
-          <a:p>
-            <a:fld id="{CE5E9CC1-C706-0F49-92D6-E571CC5EEA8F}" type="slidenum">
-              <a:rPr lang="en-US"/>
-              <a:t>‹#›</a:t>
-            </a:fld>
-            <a:endParaRPr lang="en-US"/>
-          </a:p>
-        </p:txBody>
-      </p:sp>
     </p:spTree>
     <p:extLst>
       <p:ext uri="{BB962C8B-B14F-4D97-AF65-F5344CB8AC3E}">
-        <p14:creationId xmlns:p14="http://schemas.microsoft.com/office/powerpoint/2010/main" val="1024086991"/>
+        <p14:creationId xmlns:p14="http://schemas.microsoft.com/office/powerpoint/2010/main" val="2511225351"/>
       </p:ext>
     </p:extLst>
   </p:cSld>
   <p:clrMap bg1="lt1" tx1="dk1" bg2="lt2" tx2="dk2" accent1="accent1" accent2="accent2" accent3="accent3" accent4="accent4" accent5="accent5" accent6="accent6" hlink="hlink" folHlink="folHlink"/>
   <p:notesStyle>
-    <a:lvl1pPr marL="0" algn="l" defTabSz="914400" rtl="0" eaLnBrk="1" latinLnBrk="0" hangingPunct="1">
+    <a:lvl1pPr marL="0" algn="r" defTabSz="914400" rtl="1" eaLnBrk="1" latinLnBrk="0" hangingPunct="1">
       <a:defRPr sz="1200" kern="1200">
         <a:solidFill>
           <a:schemeClr val="tx1"/>
@@ -379,7 +160,7 @@
         <a:cs typeface="+mn-cs"/>
       </a:defRPr>
     </a:lvl1pPr>
-    <a:lvl2pPr marL="457200" algn="l" defTabSz="914400" rtl="0" eaLnBrk="1" latinLnBrk="0" hangingPunct="1">
+    <a:lvl2pPr marL="457200" algn="r" defTabSz="914400" rtl="1" eaLnBrk="1" latinLnBrk="0" hangingPunct="1">
       <a:defRPr sz="1200" kern="1200">
         <a:solidFill>
           <a:schemeClr val="tx1"/>
@@ -389,7 +170,7 @@
         <a:cs typeface="+mn-cs"/>
       </a:defRPr>
     </a:lvl2pPr>
-    <a:lvl3pPr marL="914400" algn="l" defTabSz="914400" rtl="0" eaLnBrk="1" latinLnBrk="0" hangingPunct="1">
+    <a:lvl3pPr marL="914400" algn="r" defTabSz="914400" rtl="1" eaLnBrk="1" latinLnBrk="0" hangingPunct="1">
       <a:defRPr sz="1200" kern="1200">
         <a:solidFill>
           <a:schemeClr val="tx1"/>
@@ -399,7 +180,7 @@
         <a:cs typeface="+mn-cs"/>
       </a:defRPr>
     </a:lvl3pPr>
-    <a:lvl4pPr marL="1371600" algn="l" defTabSz="914400" rtl="0" eaLnBrk="1" latinLnBrk="0" hangingPunct="1">
+    <a:lvl4pPr marL="1371600" algn="r" defTabSz="914400" rtl="1" eaLnBrk="1" latinLnBrk="0" hangingPunct="1">
       <a:defRPr sz="1200" kern="1200">
         <a:solidFill>
           <a:schemeClr val="tx1"/>
@@ -409,7 +190,7 @@
         <a:cs typeface="+mn-cs"/>
       </a:defRPr>
     </a:lvl4pPr>
-    <a:lvl5pPr marL="1828800" algn="l" defTabSz="914400" rtl="0" eaLnBrk="1" latinLnBrk="0" hangingPunct="1">
+    <a:lvl5pPr marL="1828800" algn="r" defTabSz="914400" rtl="1" eaLnBrk="1" latinLnBrk="0" hangingPunct="1">
       <a:defRPr sz="1200" kern="1200">
         <a:solidFill>
           <a:schemeClr val="tx1"/>
@@ -419,7 +200,7 @@
         <a:cs typeface="+mn-cs"/>
       </a:defRPr>
     </a:lvl5pPr>
-    <a:lvl6pPr marL="2286000" algn="l" defTabSz="914400" rtl="0" eaLnBrk="1" latinLnBrk="0" hangingPunct="1">
+    <a:lvl6pPr marL="2286000" algn="r" defTabSz="914400" rtl="1" eaLnBrk="1" latinLnBrk="0" hangingPunct="1">
       <a:defRPr sz="1200" kern="1200">
         <a:solidFill>
           <a:schemeClr val="tx1"/>
@@ -429,7 +210,7 @@
         <a:cs typeface="+mn-cs"/>
       </a:defRPr>
     </a:lvl6pPr>
-    <a:lvl7pPr marL="2743200" algn="l" defTabSz="914400" rtl="0" eaLnBrk="1" latinLnBrk="0" hangingPunct="1">
+    <a:lvl7pPr marL="2743200" algn="r" defTabSz="914400" rtl="1" eaLnBrk="1" latinLnBrk="0" hangingPunct="1">
       <a:defRPr sz="1200" kern="1200">
         <a:solidFill>
           <a:schemeClr val="tx1"/>
@@ -439,7 +220,7 @@
         <a:cs typeface="+mn-cs"/>
       </a:defRPr>
     </a:lvl7pPr>
-    <a:lvl8pPr marL="3200400" algn="l" defTabSz="914400" rtl="0" eaLnBrk="1" latinLnBrk="0" hangingPunct="1">
+    <a:lvl8pPr marL="3200400" algn="r" defTabSz="914400" rtl="1" eaLnBrk="1" latinLnBrk="0" hangingPunct="1">
       <a:defRPr sz="1200" kern="1200">
         <a:solidFill>
           <a:schemeClr val="tx1"/>
@@ -449,7 +230,7 @@
         <a:cs typeface="+mn-cs"/>
       </a:defRPr>
     </a:lvl8pPr>
-    <a:lvl9pPr marL="3657600" algn="l" defTabSz="914400" rtl="0" eaLnBrk="1" latinLnBrk="0" hangingPunct="1">
+    <a:lvl9pPr marL="3657600" algn="r" defTabSz="914400" rtl="1" eaLnBrk="1" latinLnBrk="0" hangingPunct="1">
       <a:defRPr sz="1200" kern="1200">
         <a:solidFill>
           <a:schemeClr val="tx1"/>
@@ -507,10 +288,6 @@
           <a:bodyPr/>
           <a:lstStyle/>
           <a:p>
-            <a:r>
-              <a:rPr lang="en-US" dirty="0"/>
-              <a:t/>
-            </a:r>
             <a:endParaRPr lang="en-US" dirty="0"/>
           </a:p>
         </p:txBody>
@@ -595,10 +372,6 @@
           <a:bodyPr/>
           <a:lstStyle/>
           <a:p>
-            <a:r>
-              <a:rPr lang="en-US" dirty="0"/>
-              <a:t/>
-            </a:r>
             <a:endParaRPr lang="en-US" dirty="0"/>
           </a:p>
         </p:txBody>
@@ -683,10 +456,6 @@
           <a:bodyPr/>
           <a:lstStyle/>
           <a:p>
-            <a:r>
-              <a:rPr lang="en-US" dirty="0"/>
-              <a:t/>
-            </a:r>
             <a:endParaRPr lang="en-US" dirty="0"/>
           </a:p>
         </p:txBody>
@@ -771,10 +540,6 @@
           <a:bodyPr/>
           <a:lstStyle/>
           <a:p>
-            <a:r>
-              <a:rPr lang="en-US" dirty="0"/>
-              <a:t/>
-            </a:r>
             <a:endParaRPr lang="en-US" dirty="0"/>
           </a:p>
         </p:txBody>
@@ -859,10 +624,6 @@
           <a:bodyPr/>
           <a:lstStyle/>
           <a:p>
-            <a:r>
-              <a:rPr lang="en-US" dirty="0"/>
-              <a:t/>
-            </a:r>
             <a:endParaRPr lang="en-US" dirty="0"/>
           </a:p>
         </p:txBody>
@@ -947,10 +708,6 @@
           <a:bodyPr/>
           <a:lstStyle/>
           <a:p>
-            <a:r>
-              <a:rPr lang="en-US" dirty="0"/>
-              <a:t/>
-            </a:r>
             <a:endParaRPr lang="en-US" dirty="0"/>
           </a:p>
         </p:txBody>
@@ -1035,10 +792,6 @@
           <a:bodyPr/>
           <a:lstStyle/>
           <a:p>
-            <a:r>
-              <a:rPr lang="en-US" dirty="0"/>
-              <a:t/>
-            </a:r>
             <a:endParaRPr lang="en-US" dirty="0"/>
           </a:p>
         </p:txBody>
@@ -1123,10 +876,6 @@
           <a:bodyPr/>
           <a:lstStyle/>
           <a:p>
-            <a:r>
-              <a:rPr lang="en-US" dirty="0"/>
-              <a:t/>
-            </a:r>
             <a:endParaRPr lang="en-US" dirty="0"/>
           </a:p>
         </p:txBody>
@@ -1200,6 +949,11 @@
 <file path=ppt/slideMasters/slideMaster1.xml><?xml version="1.0" encoding="utf-8"?>
 <p:sldMaster xmlns:a="http://schemas.openxmlformats.org/drawingml/2006/main" xmlns:r="http://schemas.openxmlformats.org/officeDocument/2006/relationships" xmlns:p="http://schemas.openxmlformats.org/presentationml/2006/main">
   <p:cSld>
+    <p:bg>
+      <p:bgRef idx="1001">
+        <a:schemeClr val="bg1"/>
+      </p:bgRef>
+    </p:bg>
     <p:spTree>
       <p:nvGrpSpPr>
         <p:cNvPr id="1" name=""/>
@@ -1482,6 +1236,7 @@
         <a:solidFill>
           <a:srgbClr val="0F1923"/>
         </a:solidFill>
+        <a:effectLst/>
       </p:bgPr>
     </p:bg>
     <p:spTree>
@@ -1517,33 +1272,13 @@
           </a:solidFill>
           <a:ln/>
         </p:spPr>
-      </p:sp>
-      <p:sp>
-        <p:nvSpPr>
-          <p:cNvPr id="3" name="Shape 1"/>
-          <p:cNvSpPr/>
-          <p:nvPr/>
-        </p:nvSpPr>
-        <p:spPr>
-          <a:xfrm>
-            <a:off x="7498080" y="-731520"/>
-            <a:ext cx="3200400" cy="3200400"/>
-          </a:xfrm>
-          <a:prstGeom prst="ellipse">
-            <a:avLst/>
-          </a:prstGeom>
-          <a:solidFill>
-            <a:srgbClr val="1B6B6B">
-              <a:alpha val="15000"/>
-            </a:srgbClr>
-          </a:solidFill>
-          <a:ln w="12700">
-            <a:solidFill>
-              <a:srgbClr val="1B6B6B"/>
-            </a:solidFill>
-            <a:prstDash val="solid"/>
-          </a:ln>
-        </p:spPr>
+        <p:txBody>
+          <a:bodyPr/>
+          <a:lstStyle/>
+          <a:p>
+            <a:endParaRPr lang="he-IL"/>
+          </a:p>
+        </p:txBody>
       </p:sp>
       <p:sp>
         <p:nvSpPr>
@@ -1566,7 +1301,7 @@
           <a:bodyPr wrap="square" rtlCol="0" anchor="ctr"/>
           <a:lstStyle/>
           <a:p>
-            <a:pPr rtl="1" algn="r" indent="0" marL="0">
+            <a:pPr marL="0" indent="0" algn="r" rtl="1">
               <a:buNone/>
             </a:pPr>
             <a:r>
@@ -1605,7 +1340,7 @@
           <a:bodyPr wrap="square" rtlCol="0" anchor="ctr"/>
           <a:lstStyle/>
           <a:p>
-            <a:pPr rtl="1" algn="r" indent="0" marL="0">
+            <a:pPr marL="0" indent="0" algn="r" rtl="1">
               <a:buNone/>
             </a:pPr>
             <a:r>
@@ -1644,7 +1379,7 @@
           <a:bodyPr wrap="square" rtlCol="0" anchor="ctr"/>
           <a:lstStyle/>
           <a:p>
-            <a:pPr algn="r" indent="0" marL="0">
+            <a:pPr marL="0" indent="0" algn="r">
               <a:buNone/>
             </a:pPr>
             <a:r>
@@ -1684,6 +1419,13 @@
             <a:prstDash val="solid"/>
           </a:ln>
         </p:spPr>
+        <p:txBody>
+          <a:bodyPr/>
+          <a:lstStyle/>
+          <a:p>
+            <a:endParaRPr lang="he-IL"/>
+          </a:p>
+        </p:txBody>
       </p:sp>
       <p:sp>
         <p:nvSpPr>
@@ -1706,7 +1448,7 @@
           <a:bodyPr wrap="square" rtlCol="0" anchor="ctr"/>
           <a:lstStyle/>
           <a:p>
-            <a:pPr algn="r" indent="0" marL="0">
+            <a:pPr marL="0" indent="0" algn="r">
               <a:buNone/>
             </a:pPr>
             <a:r>
@@ -1720,9 +1462,6 @@
               </a:rPr>
               <a:t>שקד עקריש</a:t>
             </a:r>
-            <a:pPr algn="r" indent="0" marL="0">
-              <a:buNone/>
-            </a:pPr>
             <a:r>
               <a:rPr lang="en-US" sz="1400" dirty="0">
                 <a:solidFill>
@@ -1759,7 +1498,7 @@
           <a:bodyPr wrap="square" rtlCol="0" anchor="ctr"/>
           <a:lstStyle/>
           <a:p>
-            <a:pPr algn="r" indent="0" marL="0">
+            <a:pPr marL="0" indent="0" algn="r">
               <a:buNone/>
             </a:pPr>
             <a:r>
@@ -1801,6 +1540,13 @@
             <a:prstDash val="solid"/>
           </a:ln>
         </p:spPr>
+        <p:txBody>
+          <a:bodyPr/>
+          <a:lstStyle/>
+          <a:p>
+            <a:endParaRPr lang="he-IL"/>
+          </a:p>
+        </p:txBody>
       </p:sp>
       <p:sp>
         <p:nvSpPr>
@@ -1823,7 +1569,7 @@
           <a:bodyPr wrap="square" rtlCol="0" anchor="ctr"/>
           <a:lstStyle/>
           <a:p>
-            <a:pPr algn="ctr" indent="0" marL="0">
+            <a:pPr marL="0" indent="0" algn="ctr">
               <a:buNone/>
             </a:pPr>
             <a:r>
@@ -1865,6 +1611,13 @@
             <a:prstDash val="solid"/>
           </a:ln>
         </p:spPr>
+        <p:txBody>
+          <a:bodyPr/>
+          <a:lstStyle/>
+          <a:p>
+            <a:endParaRPr lang="he-IL"/>
+          </a:p>
+        </p:txBody>
       </p:sp>
       <p:sp>
         <p:nvSpPr>
@@ -1887,7 +1640,7 @@
           <a:bodyPr wrap="square" rtlCol="0" anchor="ctr"/>
           <a:lstStyle/>
           <a:p>
-            <a:pPr algn="ctr" indent="0" marL="0">
+            <a:pPr marL="0" indent="0" algn="ctr">
               <a:buNone/>
             </a:pPr>
             <a:r>
@@ -1929,6 +1682,13 @@
             <a:prstDash val="solid"/>
           </a:ln>
         </p:spPr>
+        <p:txBody>
+          <a:bodyPr/>
+          <a:lstStyle/>
+          <a:p>
+            <a:endParaRPr lang="he-IL"/>
+          </a:p>
+        </p:txBody>
       </p:sp>
       <p:sp>
         <p:nvSpPr>
@@ -1951,7 +1711,7 @@
           <a:bodyPr wrap="square" rtlCol="0" anchor="ctr"/>
           <a:lstStyle/>
           <a:p>
-            <a:pPr algn="ctr" indent="0" marL="0">
+            <a:pPr marL="0" indent="0" algn="ctr">
               <a:buNone/>
             </a:pPr>
             <a:r>
@@ -1993,6 +1753,13 @@
             <a:prstDash val="solid"/>
           </a:ln>
         </p:spPr>
+        <p:txBody>
+          <a:bodyPr/>
+          <a:lstStyle/>
+          <a:p>
+            <a:endParaRPr lang="he-IL"/>
+          </a:p>
+        </p:txBody>
       </p:sp>
       <p:sp>
         <p:nvSpPr>
@@ -2015,7 +1782,7 @@
           <a:bodyPr wrap="square" rtlCol="0" anchor="ctr"/>
           <a:lstStyle/>
           <a:p>
-            <a:pPr algn="ctr" indent="0" marL="0">
+            <a:pPr marL="0" indent="0" algn="ctr">
               <a:buNone/>
             </a:pPr>
             <a:r>
@@ -2057,6 +1824,13 @@
             <a:prstDash val="solid"/>
           </a:ln>
         </p:spPr>
+        <p:txBody>
+          <a:bodyPr/>
+          <a:lstStyle/>
+          <a:p>
+            <a:endParaRPr lang="he-IL"/>
+          </a:p>
+        </p:txBody>
       </p:sp>
       <p:sp>
         <p:nvSpPr>
@@ -2079,7 +1853,7 @@
           <a:bodyPr wrap="square" rtlCol="0" anchor="ctr"/>
           <a:lstStyle/>
           <a:p>
-            <a:pPr algn="ctr" indent="0" marL="0">
+            <a:pPr marL="0" indent="0" algn="ctr">
               <a:buNone/>
             </a:pPr>
             <a:r>
@@ -2121,6 +1895,13 @@
             <a:prstDash val="solid"/>
           </a:ln>
         </p:spPr>
+        <p:txBody>
+          <a:bodyPr/>
+          <a:lstStyle/>
+          <a:p>
+            <a:endParaRPr lang="he-IL"/>
+          </a:p>
+        </p:txBody>
       </p:sp>
       <p:sp>
         <p:nvSpPr>
@@ -2143,7 +1924,7 @@
           <a:bodyPr wrap="square" rtlCol="0" anchor="ctr"/>
           <a:lstStyle/>
           <a:p>
-            <a:pPr algn="ctr" indent="0" marL="0">
+            <a:pPr marL="0" indent="0" algn="ctr">
               <a:buNone/>
             </a:pPr>
             <a:r>
@@ -2177,6 +1958,7 @@
         <a:solidFill>
           <a:srgbClr val="0F1923"/>
         </a:solidFill>
+        <a:effectLst/>
       </p:bgPr>
     </p:bg>
     <p:spTree>
@@ -2212,6 +1994,13 @@
           </a:solidFill>
           <a:ln/>
         </p:spPr>
+        <p:txBody>
+          <a:bodyPr/>
+          <a:lstStyle/>
+          <a:p>
+            <a:endParaRPr lang="he-IL"/>
+          </a:p>
+        </p:txBody>
       </p:sp>
       <p:sp>
         <p:nvSpPr>
@@ -2234,7 +2023,7 @@
           <a:bodyPr wrap="square" rtlCol="0" anchor="ctr"/>
           <a:lstStyle/>
           <a:p>
-            <a:pPr rtl="1" algn="r" indent="0" marL="0">
+            <a:pPr marL="0" indent="0" algn="r" rtl="1">
               <a:buNone/>
             </a:pPr>
             <a:r>
@@ -2276,6 +2065,13 @@
             <a:prstDash val="solid"/>
           </a:ln>
         </p:spPr>
+        <p:txBody>
+          <a:bodyPr/>
+          <a:lstStyle/>
+          <a:p>
+            <a:endParaRPr lang="he-IL"/>
+          </a:p>
+        </p:txBody>
       </p:sp>
       <p:sp>
         <p:nvSpPr>
@@ -2298,7 +2094,7 @@
           <a:bodyPr wrap="square" rtlCol="0" anchor="ctr"/>
           <a:lstStyle/>
           <a:p>
-            <a:pPr algn="ctr" indent="0" marL="0">
+            <a:pPr marL="0" indent="0" algn="ctr">
               <a:buNone/>
             </a:pPr>
             <a:r>
@@ -2337,7 +2133,7 @@
           <a:bodyPr wrap="square" rtlCol="0" anchor="t"/>
           <a:lstStyle/>
           <a:p>
-            <a:pPr algn="ctr" indent="0" marL="0">
+            <a:pPr marL="0" indent="0" algn="ctr">
               <a:buNone/>
             </a:pPr>
             <a:r>
@@ -2354,7 +2150,7 @@
             <a:endParaRPr lang="en-US" sz="1200" dirty="0"/>
           </a:p>
           <a:p>
-            <a:pPr algn="ctr" indent="0" marL="0">
+            <a:pPr marL="0" indent="0" algn="ctr">
               <a:buNone/>
             </a:pPr>
             <a:r>
@@ -2396,6 +2192,13 @@
             <a:prstDash val="solid"/>
           </a:ln>
         </p:spPr>
+        <p:txBody>
+          <a:bodyPr/>
+          <a:lstStyle/>
+          <a:p>
+            <a:endParaRPr lang="he-IL"/>
+          </a:p>
+        </p:txBody>
       </p:sp>
       <p:sp>
         <p:nvSpPr>
@@ -2418,7 +2221,7 @@
           <a:bodyPr wrap="square" rtlCol="0" anchor="ctr"/>
           <a:lstStyle/>
           <a:p>
-            <a:pPr algn="ctr" indent="0" marL="0">
+            <a:pPr marL="0" indent="0" algn="ctr">
               <a:buNone/>
             </a:pPr>
             <a:r>
@@ -2457,7 +2260,7 @@
           <a:bodyPr wrap="square" rtlCol="0" anchor="t"/>
           <a:lstStyle/>
           <a:p>
-            <a:pPr algn="ctr" indent="0" marL="0">
+            <a:pPr marL="0" indent="0" algn="ctr">
               <a:buNone/>
             </a:pPr>
             <a:r>
@@ -2474,7 +2277,7 @@
             <a:endParaRPr lang="en-US" sz="1200" dirty="0"/>
           </a:p>
           <a:p>
-            <a:pPr algn="ctr" indent="0" marL="0">
+            <a:pPr marL="0" indent="0" algn="ctr">
               <a:buNone/>
             </a:pPr>
             <a:r>
@@ -2516,6 +2319,13 @@
             <a:prstDash val="solid"/>
           </a:ln>
         </p:spPr>
+        <p:txBody>
+          <a:bodyPr/>
+          <a:lstStyle/>
+          <a:p>
+            <a:endParaRPr lang="he-IL"/>
+          </a:p>
+        </p:txBody>
       </p:sp>
       <p:sp>
         <p:nvSpPr>
@@ -2538,7 +2348,7 @@
           <a:bodyPr wrap="square" rtlCol="0" anchor="ctr"/>
           <a:lstStyle/>
           <a:p>
-            <a:pPr algn="ctr" indent="0" marL="0">
+            <a:pPr marL="0" indent="0" algn="ctr">
               <a:buNone/>
             </a:pPr>
             <a:r>
@@ -2577,7 +2387,7 @@
           <a:bodyPr wrap="square" rtlCol="0" anchor="t"/>
           <a:lstStyle/>
           <a:p>
-            <a:pPr algn="ctr" indent="0" marL="0">
+            <a:pPr marL="0" indent="0" algn="ctr">
               <a:buNone/>
             </a:pPr>
             <a:r>
@@ -2594,7 +2404,7 @@
             <a:endParaRPr lang="en-US" sz="1200" dirty="0"/>
           </a:p>
           <a:p>
-            <a:pPr algn="ctr" indent="0" marL="0">
+            <a:pPr marL="0" indent="0" algn="ctr">
               <a:buNone/>
             </a:pPr>
             <a:r>
@@ -2636,6 +2446,13 @@
             <a:prstDash val="solid"/>
           </a:ln>
         </p:spPr>
+        <p:txBody>
+          <a:bodyPr/>
+          <a:lstStyle/>
+          <a:p>
+            <a:endParaRPr lang="he-IL"/>
+          </a:p>
+        </p:txBody>
       </p:sp>
       <p:sp>
         <p:nvSpPr>
@@ -2658,7 +2475,7 @@
           <a:bodyPr wrap="square" rtlCol="0" anchor="ctr"/>
           <a:lstStyle/>
           <a:p>
-            <a:pPr algn="ctr" indent="0" marL="0">
+            <a:pPr marL="0" indent="0" algn="ctr">
               <a:buNone/>
             </a:pPr>
             <a:r>
@@ -2697,7 +2514,7 @@
           <a:bodyPr wrap="square" rtlCol="0" anchor="t"/>
           <a:lstStyle/>
           <a:p>
-            <a:pPr algn="ctr" indent="0" marL="0">
+            <a:pPr marL="0" indent="0" algn="ctr">
               <a:buNone/>
             </a:pPr>
             <a:r>
@@ -2714,7 +2531,7 @@
             <a:endParaRPr lang="en-US" sz="1200" dirty="0"/>
           </a:p>
           <a:p>
-            <a:pPr algn="ctr" indent="0" marL="0">
+            <a:pPr marL="0" indent="0" algn="ctr">
               <a:buNone/>
             </a:pPr>
             <a:r>
@@ -2751,6 +2568,13 @@
           </a:solidFill>
           <a:ln/>
         </p:spPr>
+        <p:txBody>
+          <a:bodyPr/>
+          <a:lstStyle/>
+          <a:p>
+            <a:endParaRPr lang="he-IL"/>
+          </a:p>
+        </p:txBody>
       </p:sp>
       <p:sp>
         <p:nvSpPr>
@@ -2773,7 +2597,7 @@
           <a:bodyPr wrap="square" rtlCol="0" anchor="ctr"/>
           <a:lstStyle/>
           <a:p>
-            <a:pPr rtl="1" algn="r" indent="0" marL="0">
+            <a:pPr marL="0" indent="0" algn="r" rtl="1">
               <a:buNone/>
             </a:pPr>
             <a:r>
@@ -2810,6 +2634,13 @@
           </a:solidFill>
           <a:ln/>
         </p:spPr>
+        <p:txBody>
+          <a:bodyPr/>
+          <a:lstStyle/>
+          <a:p>
+            <a:endParaRPr lang="he-IL"/>
+          </a:p>
+        </p:txBody>
       </p:sp>
       <p:sp>
         <p:nvSpPr>
@@ -2832,7 +2663,7 @@
           <a:bodyPr wrap="square" rtlCol="0" anchor="ctr"/>
           <a:lstStyle/>
           <a:p>
-            <a:pPr rtl="1" algn="r" indent="0" marL="0">
+            <a:pPr marL="0" indent="0" algn="r" rtl="1">
               <a:buNone/>
             </a:pPr>
             <a:r>
@@ -2869,6 +2700,13 @@
           </a:solidFill>
           <a:ln/>
         </p:spPr>
+        <p:txBody>
+          <a:bodyPr/>
+          <a:lstStyle/>
+          <a:p>
+            <a:endParaRPr lang="he-IL"/>
+          </a:p>
+        </p:txBody>
       </p:sp>
       <p:sp>
         <p:nvSpPr>
@@ -2891,7 +2729,7 @@
           <a:bodyPr wrap="square" rtlCol="0" anchor="ctr"/>
           <a:lstStyle/>
           <a:p>
-            <a:pPr rtl="1" algn="r" indent="0" marL="0">
+            <a:pPr marL="0" indent="0" algn="r" rtl="1">
               <a:buNone/>
             </a:pPr>
             <a:r>
@@ -2928,6 +2766,13 @@
           </a:solidFill>
           <a:ln/>
         </p:spPr>
+        <p:txBody>
+          <a:bodyPr/>
+          <a:lstStyle/>
+          <a:p>
+            <a:endParaRPr lang="he-IL"/>
+          </a:p>
+        </p:txBody>
       </p:sp>
       <p:sp>
         <p:nvSpPr>
@@ -2950,7 +2795,7 @@
           <a:bodyPr wrap="square" rtlCol="0" anchor="ctr"/>
           <a:lstStyle/>
           <a:p>
-            <a:pPr rtl="1" algn="r" indent="0" marL="0">
+            <a:pPr marL="0" indent="0" algn="r" rtl="1">
               <a:buNone/>
             </a:pPr>
             <a:r>
@@ -2984,6 +2829,7 @@
         <a:solidFill>
           <a:srgbClr val="0F1923"/>
         </a:solidFill>
+        <a:effectLst/>
       </p:bgPr>
     </p:bg>
     <p:spTree>
@@ -3019,6 +2865,13 @@
           </a:solidFill>
           <a:ln/>
         </p:spPr>
+        <p:txBody>
+          <a:bodyPr/>
+          <a:lstStyle/>
+          <a:p>
+            <a:endParaRPr lang="he-IL"/>
+          </a:p>
+        </p:txBody>
       </p:sp>
       <p:sp>
         <p:nvSpPr>
@@ -3041,7 +2894,7 @@
           <a:bodyPr wrap="square" rtlCol="0" anchor="ctr"/>
           <a:lstStyle/>
           <a:p>
-            <a:pPr rtl="1" algn="r" indent="0" marL="0">
+            <a:pPr marL="0" indent="0" algn="r" rtl="1">
               <a:buNone/>
             </a:pPr>
             <a:r>
@@ -3083,6 +2936,13 @@
             <a:prstDash val="solid"/>
           </a:ln>
         </p:spPr>
+        <p:txBody>
+          <a:bodyPr/>
+          <a:lstStyle/>
+          <a:p>
+            <a:endParaRPr lang="he-IL"/>
+          </a:p>
+        </p:txBody>
       </p:sp>
       <p:sp>
         <p:nvSpPr>
@@ -3103,6 +2963,13 @@
           </a:solidFill>
           <a:ln/>
         </p:spPr>
+        <p:txBody>
+          <a:bodyPr/>
+          <a:lstStyle/>
+          <a:p>
+            <a:endParaRPr lang="he-IL"/>
+          </a:p>
+        </p:txBody>
       </p:sp>
       <p:sp>
         <p:nvSpPr>
@@ -3125,7 +2992,7 @@
           <a:bodyPr wrap="square" rtlCol="0" anchor="ctr"/>
           <a:lstStyle/>
           <a:p>
-            <a:pPr algn="ctr" indent="0" marL="0">
+            <a:pPr marL="0" indent="0" algn="ctr">
               <a:buNone/>
             </a:pPr>
             <a:r>
@@ -3161,7 +3028,7 @@
           <a:bodyPr wrap="square" rtlCol="0" anchor="ctr"/>
           <a:lstStyle/>
           <a:p>
-            <a:pPr algn="ctr" indent="0" marL="0">
+            <a:pPr marL="0" indent="0" algn="ctr">
               <a:buNone/>
             </a:pPr>
             <a:r>
@@ -3200,7 +3067,7 @@
           <a:bodyPr wrap="square" rtlCol="0" anchor="ctr"/>
           <a:lstStyle/>
           <a:p>
-            <a:pPr algn="ctr" indent="0" marL="0">
+            <a:pPr marL="0" indent="0" algn="ctr">
               <a:buNone/>
             </a:pPr>
             <a:r>
@@ -3217,7 +3084,7 @@
             <a:endParaRPr lang="en-US" sz="950" dirty="0"/>
           </a:p>
           <a:p>
-            <a:pPr algn="ctr" indent="0" marL="0">
+            <a:pPr marL="0" indent="0" algn="ctr">
               <a:buNone/>
             </a:pPr>
             <a:r>
@@ -3257,6 +3124,13 @@
             <a:prstDash val="solid"/>
           </a:ln>
         </p:spPr>
+        <p:txBody>
+          <a:bodyPr/>
+          <a:lstStyle/>
+          <a:p>
+            <a:endParaRPr lang="he-IL"/>
+          </a:p>
+        </p:txBody>
       </p:sp>
       <p:sp>
         <p:nvSpPr>
@@ -3282,6 +3156,13 @@
             <a:prstDash val="solid"/>
           </a:ln>
         </p:spPr>
+        <p:txBody>
+          <a:bodyPr/>
+          <a:lstStyle/>
+          <a:p>
+            <a:endParaRPr lang="he-IL"/>
+          </a:p>
+        </p:txBody>
       </p:sp>
       <p:sp>
         <p:nvSpPr>
@@ -3302,6 +3183,13 @@
           </a:solidFill>
           <a:ln/>
         </p:spPr>
+        <p:txBody>
+          <a:bodyPr/>
+          <a:lstStyle/>
+          <a:p>
+            <a:endParaRPr lang="he-IL"/>
+          </a:p>
+        </p:txBody>
       </p:sp>
       <p:sp>
         <p:nvSpPr>
@@ -3324,7 +3212,7 @@
           <a:bodyPr wrap="square" rtlCol="0" anchor="ctr"/>
           <a:lstStyle/>
           <a:p>
-            <a:pPr algn="ctr" indent="0" marL="0">
+            <a:pPr marL="0" indent="0" algn="ctr">
               <a:buNone/>
             </a:pPr>
             <a:r>
@@ -3360,7 +3248,7 @@
           <a:bodyPr wrap="square" rtlCol="0" anchor="ctr"/>
           <a:lstStyle/>
           <a:p>
-            <a:pPr algn="ctr" indent="0" marL="0">
+            <a:pPr marL="0" indent="0" algn="ctr">
               <a:buNone/>
             </a:pPr>
             <a:r>
@@ -3399,7 +3287,7 @@
           <a:bodyPr wrap="square" rtlCol="0" anchor="ctr"/>
           <a:lstStyle/>
           <a:p>
-            <a:pPr algn="ctr" indent="0" marL="0">
+            <a:pPr marL="0" indent="0" algn="ctr">
               <a:buNone/>
             </a:pPr>
             <a:r>
@@ -3416,7 +3304,7 @@
             <a:endParaRPr lang="en-US" sz="950" dirty="0"/>
           </a:p>
           <a:p>
-            <a:pPr algn="ctr" indent="0" marL="0">
+            <a:pPr marL="0" indent="0" algn="ctr">
               <a:buNone/>
             </a:pPr>
             <a:r>
@@ -3456,6 +3344,13 @@
             <a:prstDash val="solid"/>
           </a:ln>
         </p:spPr>
+        <p:txBody>
+          <a:bodyPr/>
+          <a:lstStyle/>
+          <a:p>
+            <a:endParaRPr lang="he-IL"/>
+          </a:p>
+        </p:txBody>
       </p:sp>
       <p:sp>
         <p:nvSpPr>
@@ -3481,6 +3376,13 @@
             <a:prstDash val="solid"/>
           </a:ln>
         </p:spPr>
+        <p:txBody>
+          <a:bodyPr/>
+          <a:lstStyle/>
+          <a:p>
+            <a:endParaRPr lang="he-IL"/>
+          </a:p>
+        </p:txBody>
       </p:sp>
       <p:sp>
         <p:nvSpPr>
@@ -3501,6 +3403,13 @@
           </a:solidFill>
           <a:ln/>
         </p:spPr>
+        <p:txBody>
+          <a:bodyPr/>
+          <a:lstStyle/>
+          <a:p>
+            <a:endParaRPr lang="he-IL"/>
+          </a:p>
+        </p:txBody>
       </p:sp>
       <p:sp>
         <p:nvSpPr>
@@ -3523,7 +3432,7 @@
           <a:bodyPr wrap="square" rtlCol="0" anchor="ctr"/>
           <a:lstStyle/>
           <a:p>
-            <a:pPr algn="ctr" indent="0" marL="0">
+            <a:pPr marL="0" indent="0" algn="ctr">
               <a:buNone/>
             </a:pPr>
             <a:r>
@@ -3559,7 +3468,7 @@
           <a:bodyPr wrap="square" rtlCol="0" anchor="ctr"/>
           <a:lstStyle/>
           <a:p>
-            <a:pPr algn="ctr" indent="0" marL="0">
+            <a:pPr marL="0" indent="0" algn="ctr">
               <a:buNone/>
             </a:pPr>
             <a:r>
@@ -3598,7 +3507,7 @@
           <a:bodyPr wrap="square" rtlCol="0" anchor="ctr"/>
           <a:lstStyle/>
           <a:p>
-            <a:pPr algn="ctr" indent="0" marL="0">
+            <a:pPr marL="0" indent="0" algn="ctr">
               <a:buNone/>
             </a:pPr>
             <a:r>
@@ -3615,7 +3524,7 @@
             <a:endParaRPr lang="en-US" sz="950" dirty="0"/>
           </a:p>
           <a:p>
-            <a:pPr algn="ctr" indent="0" marL="0">
+            <a:pPr marL="0" indent="0" algn="ctr">
               <a:buNone/>
             </a:pPr>
             <a:r>
@@ -3655,6 +3564,13 @@
             <a:prstDash val="solid"/>
           </a:ln>
         </p:spPr>
+        <p:txBody>
+          <a:bodyPr/>
+          <a:lstStyle/>
+          <a:p>
+            <a:endParaRPr lang="he-IL"/>
+          </a:p>
+        </p:txBody>
       </p:sp>
       <p:sp>
         <p:nvSpPr>
@@ -3680,6 +3596,13 @@
             <a:prstDash val="solid"/>
           </a:ln>
         </p:spPr>
+        <p:txBody>
+          <a:bodyPr/>
+          <a:lstStyle/>
+          <a:p>
+            <a:endParaRPr lang="he-IL"/>
+          </a:p>
+        </p:txBody>
       </p:sp>
       <p:sp>
         <p:nvSpPr>
@@ -3700,6 +3623,13 @@
           </a:solidFill>
           <a:ln/>
         </p:spPr>
+        <p:txBody>
+          <a:bodyPr/>
+          <a:lstStyle/>
+          <a:p>
+            <a:endParaRPr lang="he-IL"/>
+          </a:p>
+        </p:txBody>
       </p:sp>
       <p:sp>
         <p:nvSpPr>
@@ -3722,7 +3652,7 @@
           <a:bodyPr wrap="square" rtlCol="0" anchor="ctr"/>
           <a:lstStyle/>
           <a:p>
-            <a:pPr algn="ctr" indent="0" marL="0">
+            <a:pPr marL="0" indent="0" algn="ctr">
               <a:buNone/>
             </a:pPr>
             <a:r>
@@ -3758,7 +3688,7 @@
           <a:bodyPr wrap="square" rtlCol="0" anchor="ctr"/>
           <a:lstStyle/>
           <a:p>
-            <a:pPr algn="ctr" indent="0" marL="0">
+            <a:pPr marL="0" indent="0" algn="ctr">
               <a:buNone/>
             </a:pPr>
             <a:r>
@@ -3797,7 +3727,7 @@
           <a:bodyPr wrap="square" rtlCol="0" anchor="ctr"/>
           <a:lstStyle/>
           <a:p>
-            <a:pPr algn="ctr" indent="0" marL="0">
+            <a:pPr marL="0" indent="0" algn="ctr">
               <a:buNone/>
             </a:pPr>
             <a:r>
@@ -3814,7 +3744,7 @@
             <a:endParaRPr lang="en-US" sz="950" dirty="0"/>
           </a:p>
           <a:p>
-            <a:pPr algn="ctr" indent="0" marL="0">
+            <a:pPr marL="0" indent="0" algn="ctr">
               <a:buNone/>
             </a:pPr>
             <a:r>
@@ -3854,6 +3784,13 @@
             <a:prstDash val="solid"/>
           </a:ln>
         </p:spPr>
+        <p:txBody>
+          <a:bodyPr/>
+          <a:lstStyle/>
+          <a:p>
+            <a:endParaRPr lang="he-IL"/>
+          </a:p>
+        </p:txBody>
       </p:sp>
       <p:sp>
         <p:nvSpPr>
@@ -3879,6 +3816,13 @@
             <a:prstDash val="solid"/>
           </a:ln>
         </p:spPr>
+        <p:txBody>
+          <a:bodyPr/>
+          <a:lstStyle/>
+          <a:p>
+            <a:endParaRPr lang="he-IL"/>
+          </a:p>
+        </p:txBody>
       </p:sp>
       <p:sp>
         <p:nvSpPr>
@@ -3899,6 +3843,13 @@
           </a:solidFill>
           <a:ln/>
         </p:spPr>
+        <p:txBody>
+          <a:bodyPr/>
+          <a:lstStyle/>
+          <a:p>
+            <a:endParaRPr lang="he-IL"/>
+          </a:p>
+        </p:txBody>
       </p:sp>
       <p:sp>
         <p:nvSpPr>
@@ -3921,7 +3872,7 @@
           <a:bodyPr wrap="square" rtlCol="0" anchor="ctr"/>
           <a:lstStyle/>
           <a:p>
-            <a:pPr algn="ctr" indent="0" marL="0">
+            <a:pPr marL="0" indent="0" algn="ctr">
               <a:buNone/>
             </a:pPr>
             <a:r>
@@ -3957,7 +3908,7 @@
           <a:bodyPr wrap="square" rtlCol="0" anchor="ctr"/>
           <a:lstStyle/>
           <a:p>
-            <a:pPr algn="ctr" indent="0" marL="0">
+            <a:pPr marL="0" indent="0" algn="ctr">
               <a:buNone/>
             </a:pPr>
             <a:r>
@@ -3996,7 +3947,7 @@
           <a:bodyPr wrap="square" rtlCol="0" anchor="ctr"/>
           <a:lstStyle/>
           <a:p>
-            <a:pPr algn="ctr" indent="0" marL="0">
+            <a:pPr marL="0" indent="0" algn="ctr">
               <a:buNone/>
             </a:pPr>
             <a:r>
@@ -4013,7 +3964,7 @@
             <a:endParaRPr lang="en-US" sz="950" dirty="0"/>
           </a:p>
           <a:p>
-            <a:pPr algn="ctr" indent="0" marL="0">
+            <a:pPr marL="0" indent="0" algn="ctr">
               <a:buNone/>
             </a:pPr>
             <a:r>
@@ -4053,6 +4004,13 @@
             <a:prstDash val="solid"/>
           </a:ln>
         </p:spPr>
+        <p:txBody>
+          <a:bodyPr/>
+          <a:lstStyle/>
+          <a:p>
+            <a:endParaRPr lang="he-IL"/>
+          </a:p>
+        </p:txBody>
       </p:sp>
       <p:sp>
         <p:nvSpPr>
@@ -4078,6 +4036,13 @@
             <a:prstDash val="solid"/>
           </a:ln>
         </p:spPr>
+        <p:txBody>
+          <a:bodyPr/>
+          <a:lstStyle/>
+          <a:p>
+            <a:endParaRPr lang="he-IL"/>
+          </a:p>
+        </p:txBody>
       </p:sp>
       <p:sp>
         <p:nvSpPr>
@@ -4098,6 +4063,13 @@
           </a:solidFill>
           <a:ln/>
         </p:spPr>
+        <p:txBody>
+          <a:bodyPr/>
+          <a:lstStyle/>
+          <a:p>
+            <a:endParaRPr lang="he-IL"/>
+          </a:p>
+        </p:txBody>
       </p:sp>
       <p:sp>
         <p:nvSpPr>
@@ -4120,7 +4092,7 @@
           <a:bodyPr wrap="square" rtlCol="0" anchor="ctr"/>
           <a:lstStyle/>
           <a:p>
-            <a:pPr algn="ctr" indent="0" marL="0">
+            <a:pPr marL="0" indent="0" algn="ctr">
               <a:buNone/>
             </a:pPr>
             <a:r>
@@ -4156,7 +4128,7 @@
           <a:bodyPr wrap="square" rtlCol="0" anchor="ctr"/>
           <a:lstStyle/>
           <a:p>
-            <a:pPr algn="ctr" indent="0" marL="0">
+            <a:pPr marL="0" indent="0" algn="ctr">
               <a:buNone/>
             </a:pPr>
             <a:r>
@@ -4195,7 +4167,7 @@
           <a:bodyPr wrap="square" rtlCol="0" anchor="ctr"/>
           <a:lstStyle/>
           <a:p>
-            <a:pPr algn="ctr" indent="0" marL="0">
+            <a:pPr marL="0" indent="0" algn="ctr">
               <a:buNone/>
             </a:pPr>
             <a:r>
@@ -4212,7 +4184,7 @@
             <a:endParaRPr lang="en-US" sz="950" dirty="0"/>
           </a:p>
           <a:p>
-            <a:pPr algn="ctr" indent="0" marL="0">
+            <a:pPr marL="0" indent="0" algn="ctr">
               <a:buNone/>
             </a:pPr>
             <a:r>
@@ -4253,7 +4225,7 @@
           <a:bodyPr wrap="square" rtlCol="0" anchor="ctr"/>
           <a:lstStyle/>
           <a:p>
-            <a:pPr algn="ctr" indent="0" marL="0">
+            <a:pPr marL="0" indent="0" algn="ctr">
               <a:buNone/>
             </a:pPr>
             <a:r>
@@ -4294,7 +4266,7 @@
           <a:bodyPr wrap="square" rtlCol="0" anchor="ctr"/>
           <a:lstStyle/>
           <a:p>
-            <a:pPr algn="ctr" indent="0" marL="0">
+            <a:pPr marL="0" indent="0" algn="ctr">
               <a:buNone/>
             </a:pPr>
             <a:r>
@@ -4335,7 +4307,7 @@
           <a:bodyPr wrap="square" rtlCol="0" anchor="ctr"/>
           <a:lstStyle/>
           <a:p>
-            <a:pPr algn="ctr" indent="0" marL="0">
+            <a:pPr marL="0" indent="0" algn="ctr">
               <a:buNone/>
             </a:pPr>
             <a:r>
@@ -4376,7 +4348,7 @@
           <a:bodyPr wrap="square" rtlCol="0" anchor="ctr"/>
           <a:lstStyle/>
           <a:p>
-            <a:pPr algn="ctr" indent="0" marL="0">
+            <a:pPr marL="0" indent="0" algn="ctr">
               <a:buNone/>
             </a:pPr>
             <a:r>
@@ -4417,7 +4389,7 @@
           <a:bodyPr wrap="square" rtlCol="0" anchor="ctr"/>
           <a:lstStyle/>
           <a:p>
-            <a:pPr algn="ctr" indent="0" marL="0">
+            <a:pPr marL="0" indent="0" algn="ctr">
               <a:buNone/>
             </a:pPr>
             <a:r>
@@ -4451,6 +4423,7 @@
         <a:solidFill>
           <a:srgbClr val="0F1923"/>
         </a:solidFill>
+        <a:effectLst/>
       </p:bgPr>
     </p:bg>
     <p:spTree>
@@ -4488,7 +4461,10 @@
         </p:spPr>
         <p:txBody>
           <a:bodyPr/>
-          <a:p/>
+          <a:lstStyle/>
+          <a:p>
+            <a:endParaRPr/>
+          </a:p>
         </p:txBody>
       </p:sp>
       <p:sp>
@@ -4512,7 +4488,7 @@
           <a:bodyPr wrap="square" rtlCol="0" anchor="ctr"/>
           <a:lstStyle/>
           <a:p>
-            <a:pPr rtl="1" algn="r" indent="0" marL="0">
+            <a:pPr marL="0" indent="0" algn="r" rtl="1">
               <a:buNone/>
             </a:pPr>
             <a:r>
@@ -4551,7 +4527,7 @@
           <a:bodyPr wrap="square" rtlCol="0" anchor="ctr"/>
           <a:lstStyle/>
           <a:p>
-            <a:pPr rtl="1" algn="r" indent="0" marL="0">
+            <a:pPr marL="0" indent="0" algn="r" rtl="1">
               <a:buNone/>
             </a:pPr>
             <a:r>
@@ -4590,7 +4566,10 @@
         </p:spPr>
         <p:txBody>
           <a:bodyPr/>
-          <a:p/>
+          <a:lstStyle/>
+          <a:p>
+            <a:endParaRPr/>
+          </a:p>
         </p:txBody>
       </p:sp>
       <p:sp>
@@ -4614,7 +4593,7 @@
           <a:bodyPr wrap="square" rtlCol="0" anchor="ctr"/>
           <a:lstStyle/>
           <a:p>
-            <a:pPr rtl="1" algn="r" indent="0" marL="0">
+            <a:pPr marL="0" indent="0" algn="r" rtl="1">
               <a:buNone/>
             </a:pPr>
             <a:r>
@@ -4653,7 +4632,10 @@
         </p:spPr>
         <p:txBody>
           <a:bodyPr/>
-          <a:p/>
+          <a:lstStyle/>
+          <a:p>
+            <a:endParaRPr/>
+          </a:p>
         </p:txBody>
       </p:sp>
       <p:sp>
@@ -4677,7 +4659,7 @@
           <a:bodyPr wrap="square" rtlCol="0" anchor="ctr"/>
           <a:lstStyle/>
           <a:p>
-            <a:pPr rtl="1" algn="r" indent="0" marL="0">
+            <a:pPr marL="0" indent="0" algn="r" rtl="1">
               <a:buNone/>
             </a:pPr>
             <a:r>
@@ -4716,7 +4698,10 @@
         </p:spPr>
         <p:txBody>
           <a:bodyPr/>
-          <a:p/>
+          <a:lstStyle/>
+          <a:p>
+            <a:endParaRPr/>
+          </a:p>
         </p:txBody>
       </p:sp>
       <p:sp>
@@ -4740,7 +4725,7 @@
           <a:bodyPr wrap="square" rtlCol="0" anchor="ctr"/>
           <a:lstStyle/>
           <a:p>
-            <a:pPr rtl="1" algn="r" indent="0" marL="0">
+            <a:pPr marL="0" indent="0" algn="r" rtl="1">
               <a:buNone/>
             </a:pPr>
             <a:r>
@@ -4779,7 +4764,10 @@
         </p:spPr>
         <p:txBody>
           <a:bodyPr/>
-          <a:p/>
+          <a:lstStyle/>
+          <a:p>
+            <a:endParaRPr/>
+          </a:p>
         </p:txBody>
       </p:sp>
       <p:sp>
@@ -4803,7 +4791,7 @@
           <a:bodyPr wrap="square" rtlCol="0" anchor="ctr"/>
           <a:lstStyle/>
           <a:p>
-            <a:pPr rtl="1" algn="r" indent="0" marL="0">
+            <a:pPr marL="0" indent="0" algn="r" rtl="1">
               <a:buNone/>
             </a:pPr>
             <a:r>
@@ -4842,7 +4830,10 @@
         </p:spPr>
         <p:txBody>
           <a:bodyPr/>
-          <a:p/>
+          <a:lstStyle/>
+          <a:p>
+            <a:endParaRPr/>
+          </a:p>
         </p:txBody>
       </p:sp>
       <p:sp>
@@ -4866,7 +4857,7 @@
           <a:bodyPr wrap="square" rtlCol="0" anchor="ctr"/>
           <a:lstStyle/>
           <a:p>
-            <a:pPr rtl="1" algn="r" indent="0" marL="0">
+            <a:pPr marL="0" indent="0" algn="r" rtl="1">
               <a:buNone/>
             </a:pPr>
             <a:r>
@@ -4905,7 +4896,7 @@
           <a:bodyPr wrap="square" rtlCol="0" anchor="ctr"/>
           <a:lstStyle/>
           <a:p>
-            <a:pPr algn="l" indent="0" marL="0">
+            <a:pPr marL="0" indent="0" algn="l">
               <a:buNone/>
             </a:pPr>
             <a:r>
@@ -4949,7 +4940,10 @@
         </p:spPr>
         <p:txBody>
           <a:bodyPr/>
-          <a:p/>
+          <a:lstStyle/>
+          <a:p>
+            <a:endParaRPr/>
+          </a:p>
         </p:txBody>
       </p:sp>
       <p:sp>
@@ -4973,7 +4967,7 @@
           <a:bodyPr wrap="square" rtlCol="0" anchor="ctr"/>
           <a:lstStyle/>
           <a:p>
-            <a:pPr algn="r" indent="0" marL="0">
+            <a:pPr marL="0" indent="0" algn="r">
               <a:buNone/>
             </a:pPr>
             <a:r>
@@ -5012,7 +5006,7 @@
           <a:bodyPr wrap="square" rtlCol="0" anchor="ctr"/>
           <a:lstStyle/>
           <a:p>
-            <a:pPr algn="l" indent="0" marL="0">
+            <a:pPr marL="0" indent="0" algn="l">
               <a:buNone/>
             </a:pPr>
             <a:r>
@@ -5056,7 +5050,10 @@
         </p:spPr>
         <p:txBody>
           <a:bodyPr/>
-          <a:p/>
+          <a:lstStyle/>
+          <a:p>
+            <a:endParaRPr/>
+          </a:p>
         </p:txBody>
       </p:sp>
       <p:sp>
@@ -5080,7 +5077,7 @@
           <a:bodyPr wrap="square" rtlCol="0" anchor="ctr"/>
           <a:lstStyle/>
           <a:p>
-            <a:pPr algn="r" indent="0" marL="0">
+            <a:pPr marL="0" indent="0" algn="r">
               <a:buNone/>
             </a:pPr>
             <a:r>
@@ -5119,7 +5116,7 @@
           <a:bodyPr wrap="square" rtlCol="0" anchor="ctr"/>
           <a:lstStyle/>
           <a:p>
-            <a:pPr algn="l" indent="0" marL="0">
+            <a:pPr marL="0" indent="0" algn="l">
               <a:buNone/>
             </a:pPr>
             <a:r>
@@ -5163,7 +5160,10 @@
         </p:spPr>
         <p:txBody>
           <a:bodyPr/>
-          <a:p/>
+          <a:lstStyle/>
+          <a:p>
+            <a:endParaRPr/>
+          </a:p>
         </p:txBody>
       </p:sp>
       <p:sp>
@@ -5187,7 +5187,7 @@
           <a:bodyPr wrap="square" rtlCol="0" anchor="ctr"/>
           <a:lstStyle/>
           <a:p>
-            <a:pPr algn="r" indent="0" marL="0">
+            <a:pPr marL="0" indent="0" algn="r">
               <a:buNone/>
             </a:pPr>
             <a:r>
@@ -5226,7 +5226,7 @@
           <a:bodyPr wrap="square" rtlCol="0" anchor="ctr"/>
           <a:lstStyle/>
           <a:p>
-            <a:pPr algn="l" indent="0" marL="0">
+            <a:pPr marL="0" indent="0" algn="l">
               <a:buNone/>
             </a:pPr>
             <a:r>
@@ -5270,7 +5270,10 @@
         </p:spPr>
         <p:txBody>
           <a:bodyPr/>
-          <a:p/>
+          <a:lstStyle/>
+          <a:p>
+            <a:endParaRPr/>
+          </a:p>
         </p:txBody>
       </p:sp>
       <p:sp>
@@ -5294,7 +5297,7 @@
           <a:bodyPr wrap="square" rtlCol="0" anchor="ctr"/>
           <a:lstStyle/>
           <a:p>
-            <a:pPr algn="r" indent="0" marL="0">
+            <a:pPr marL="0" indent="0" algn="r">
               <a:buNone/>
             </a:pPr>
             <a:r>
@@ -5333,7 +5336,7 @@
           <a:bodyPr wrap="square" rtlCol="0" anchor="ctr"/>
           <a:lstStyle/>
           <a:p>
-            <a:pPr algn="l" indent="0" marL="0">
+            <a:pPr marL="0" indent="0" algn="l">
               <a:buNone/>
             </a:pPr>
             <a:r>
@@ -5377,7 +5380,10 @@
         </p:spPr>
         <p:txBody>
           <a:bodyPr/>
-          <a:p/>
+          <a:lstStyle/>
+          <a:p>
+            <a:endParaRPr/>
+          </a:p>
         </p:txBody>
       </p:sp>
       <p:sp>
@@ -5401,7 +5407,7 @@
           <a:bodyPr wrap="square" rtlCol="0" anchor="ctr"/>
           <a:lstStyle/>
           <a:p>
-            <a:pPr algn="r" indent="0" marL="0">
+            <a:pPr marL="0" indent="0" algn="r">
               <a:buNone/>
             </a:pPr>
             <a:r>
@@ -5440,7 +5446,7 @@
           <a:bodyPr wrap="square" rtlCol="0" anchor="ctr"/>
           <a:lstStyle/>
           <a:p>
-            <a:pPr algn="l" indent="0" marL="0">
+            <a:pPr marL="0" indent="0" algn="l">
               <a:buNone/>
             </a:pPr>
             <a:r>
@@ -5484,7 +5490,10 @@
         </p:spPr>
         <p:txBody>
           <a:bodyPr/>
-          <a:p/>
+          <a:lstStyle/>
+          <a:p>
+            <a:endParaRPr/>
+          </a:p>
         </p:txBody>
       </p:sp>
       <p:sp>
@@ -5508,7 +5517,7 @@
           <a:bodyPr wrap="square" rtlCol="0" anchor="ctr"/>
           <a:lstStyle/>
           <a:p>
-            <a:pPr algn="r" indent="0" marL="0">
+            <a:pPr marL="0" indent="0" algn="r">
               <a:buNone/>
             </a:pPr>
             <a:r>
@@ -5547,7 +5556,7 @@
           <a:bodyPr wrap="square" rtlCol="0" anchor="ctr"/>
           <a:lstStyle/>
           <a:p>
-            <a:pPr algn="l" indent="0" marL="0">
+            <a:pPr marL="0" indent="0" algn="l">
               <a:buNone/>
             </a:pPr>
             <a:r>
@@ -5591,7 +5600,10 @@
         </p:spPr>
         <p:txBody>
           <a:bodyPr/>
-          <a:p/>
+          <a:lstStyle/>
+          <a:p>
+            <a:endParaRPr/>
+          </a:p>
         </p:txBody>
       </p:sp>
       <p:sp>
@@ -5615,20 +5627,9 @@
           <a:bodyPr wrap="square" rtlCol="0" anchor="ctr"/>
           <a:lstStyle/>
           <a:p>
-            <a:pPr algn="r" indent="0" marL="0">
-              <a:buNone/>
-            </a:pPr>
-            <a:r>
-              <a:rPr lang="en-US" sz="1100" dirty="0">
-                <a:solidFill>
-                  <a:srgbClr val="D0E8F8"/>
-                </a:solidFill>
-                <a:latin typeface="Calibri" pitchFamily="34" charset="0"/>
-                <a:ea typeface="Calibri" pitchFamily="34" charset="-122"/>
-                <a:cs typeface="Calibri" pitchFamily="34" charset="-120"/>
-              </a:rPr>
-              <a:t/>
-            </a:r>
+            <a:pPr marL="0" indent="0" algn="r">
+              <a:buNone/>
+            </a:pPr>
             <a:endParaRPr lang="en-US" sz="1100" dirty="0"/>
           </a:p>
         </p:txBody>
@@ -5654,20 +5655,9 @@
           <a:bodyPr wrap="square" rtlCol="0" anchor="ctr"/>
           <a:lstStyle/>
           <a:p>
-            <a:pPr algn="l" indent="0" marL="0">
-              <a:buNone/>
-            </a:pPr>
-            <a:r>
-              <a:rPr lang="en-US" sz="950" dirty="0">
-                <a:solidFill>
-                  <a:srgbClr val="7A9AB0"/>
-                </a:solidFill>
-                <a:latin typeface="Calibri" pitchFamily="34" charset="0"/>
-                <a:ea typeface="Calibri" pitchFamily="34" charset="-122"/>
-                <a:cs typeface="Calibri" pitchFamily="34" charset="-120"/>
-              </a:rPr>
-              <a:t/>
-            </a:r>
+            <a:pPr marL="0" indent="0" algn="l">
+              <a:buNone/>
+            </a:pPr>
             <a:endParaRPr lang="en-US" sz="950" dirty="0"/>
           </a:p>
         </p:txBody>
@@ -5698,7 +5688,10 @@
         </p:spPr>
         <p:txBody>
           <a:bodyPr/>
-          <a:p/>
+          <a:lstStyle/>
+          <a:p>
+            <a:endParaRPr/>
+          </a:p>
         </p:txBody>
       </p:sp>
       <p:sp>
@@ -5722,20 +5715,9 @@
           <a:bodyPr wrap="square" rtlCol="0" anchor="ctr"/>
           <a:lstStyle/>
           <a:p>
-            <a:pPr algn="r" indent="0" marL="0">
-              <a:buNone/>
-            </a:pPr>
-            <a:r>
-              <a:rPr lang="en-US" sz="1100" dirty="0">
-                <a:solidFill>
-                  <a:srgbClr val="D0E8F8"/>
-                </a:solidFill>
-                <a:latin typeface="Calibri" pitchFamily="34" charset="0"/>
-                <a:ea typeface="Calibri" pitchFamily="34" charset="-122"/>
-                <a:cs typeface="Calibri" pitchFamily="34" charset="-120"/>
-              </a:rPr>
-              <a:t/>
-            </a:r>
+            <a:pPr marL="0" indent="0" algn="r">
+              <a:buNone/>
+            </a:pPr>
             <a:endParaRPr lang="en-US" sz="1100" dirty="0"/>
           </a:p>
         </p:txBody>
@@ -5761,20 +5743,9 @@
           <a:bodyPr wrap="square" rtlCol="0" anchor="ctr"/>
           <a:lstStyle/>
           <a:p>
-            <a:pPr algn="l" indent="0" marL="0">
-              <a:buNone/>
-            </a:pPr>
-            <a:r>
-              <a:rPr lang="en-US" sz="950" dirty="0">
-                <a:solidFill>
-                  <a:srgbClr val="7A9AB0"/>
-                </a:solidFill>
-                <a:latin typeface="Calibri" pitchFamily="34" charset="0"/>
-                <a:ea typeface="Calibri" pitchFamily="34" charset="-122"/>
-                <a:cs typeface="Calibri" pitchFamily="34" charset="-120"/>
-              </a:rPr>
-              <a:t/>
-            </a:r>
+            <a:pPr marL="0" indent="0" algn="l">
+              <a:buNone/>
+            </a:pPr>
             <a:endParaRPr lang="en-US" sz="950" dirty="0"/>
           </a:p>
         </p:txBody>
@@ -5803,7 +5774,10 @@
         </p:spPr>
         <p:txBody>
           <a:bodyPr/>
-          <a:p/>
+          <a:lstStyle/>
+          <a:p>
+            <a:endParaRPr/>
+          </a:p>
         </p:txBody>
       </p:sp>
       <p:sp>
@@ -5827,7 +5801,7 @@
           <a:bodyPr wrap="square" rtlCol="0" anchor="ctr"/>
           <a:lstStyle/>
           <a:p>
-            <a:pPr algn="ctr" indent="0" marL="0">
+            <a:pPr marL="0" indent="0" algn="ctr">
               <a:buNone/>
             </a:pPr>
             <a:r>
@@ -5861,6 +5835,7 @@
         <a:solidFill>
           <a:srgbClr val="0F1923"/>
         </a:solidFill>
+        <a:effectLst/>
       </p:bgPr>
     </p:bg>
     <p:spTree>
@@ -5896,6 +5871,13 @@
           </a:solidFill>
           <a:ln/>
         </p:spPr>
+        <p:txBody>
+          <a:bodyPr/>
+          <a:lstStyle/>
+          <a:p>
+            <a:endParaRPr lang="he-IL"/>
+          </a:p>
+        </p:txBody>
       </p:sp>
       <p:sp>
         <p:nvSpPr>
@@ -5918,7 +5900,7 @@
           <a:bodyPr wrap="square" rtlCol="0" anchor="ctr"/>
           <a:lstStyle/>
           <a:p>
-            <a:pPr rtl="1" algn="r" indent="0" marL="0">
+            <a:pPr marL="0" indent="0" algn="r" rtl="1">
               <a:buNone/>
             </a:pPr>
             <a:r>
@@ -5960,6 +5942,13 @@
             <a:prstDash val="solid"/>
           </a:ln>
         </p:spPr>
+        <p:txBody>
+          <a:bodyPr/>
+          <a:lstStyle/>
+          <a:p>
+            <a:endParaRPr lang="he-IL"/>
+          </a:p>
+        </p:txBody>
       </p:sp>
       <p:sp>
         <p:nvSpPr>
@@ -5980,6 +5969,13 @@
           </a:solidFill>
           <a:ln/>
         </p:spPr>
+        <p:txBody>
+          <a:bodyPr/>
+          <a:lstStyle/>
+          <a:p>
+            <a:endParaRPr lang="he-IL"/>
+          </a:p>
+        </p:txBody>
       </p:sp>
       <p:sp>
         <p:nvSpPr>
@@ -6002,7 +5998,7 @@
           <a:bodyPr wrap="square" rtlCol="0" anchor="ctr"/>
           <a:lstStyle/>
           <a:p>
-            <a:pPr algn="ctr" indent="0" marL="0">
+            <a:pPr marL="0" indent="0" algn="ctr">
               <a:buNone/>
             </a:pPr>
             <a:r>
@@ -6041,7 +6037,7 @@
           <a:bodyPr wrap="square" rtlCol="0" anchor="ctr"/>
           <a:lstStyle/>
           <a:p>
-            <a:pPr algn="ctr" indent="0" marL="0">
+            <a:pPr marL="0" indent="0" algn="ctr">
               <a:buNone/>
             </a:pPr>
             <a:r>
@@ -6080,7 +6076,7 @@
           <a:bodyPr wrap="square" rtlCol="0" anchor="ctr"/>
           <a:lstStyle/>
           <a:p>
-            <a:pPr algn="ctr" indent="0" marL="0">
+            <a:pPr marL="0" indent="0" algn="ctr">
               <a:buNone/>
             </a:pPr>
             <a:r>
@@ -6122,6 +6118,13 @@
             <a:prstDash val="solid"/>
           </a:ln>
         </p:spPr>
+        <p:txBody>
+          <a:bodyPr/>
+          <a:lstStyle/>
+          <a:p>
+            <a:endParaRPr lang="he-IL"/>
+          </a:p>
+        </p:txBody>
       </p:sp>
       <p:sp>
         <p:nvSpPr>
@@ -6142,6 +6145,13 @@
           </a:solidFill>
           <a:ln/>
         </p:spPr>
+        <p:txBody>
+          <a:bodyPr/>
+          <a:lstStyle/>
+          <a:p>
+            <a:endParaRPr lang="he-IL"/>
+          </a:p>
+        </p:txBody>
       </p:sp>
       <p:sp>
         <p:nvSpPr>
@@ -6164,7 +6174,7 @@
           <a:bodyPr wrap="square" rtlCol="0" anchor="ctr"/>
           <a:lstStyle/>
           <a:p>
-            <a:pPr algn="ctr" indent="0" marL="0">
+            <a:pPr marL="0" indent="0" algn="ctr">
               <a:buNone/>
             </a:pPr>
             <a:r>
@@ -6203,7 +6213,7 @@
           <a:bodyPr wrap="square" rtlCol="0" anchor="ctr"/>
           <a:lstStyle/>
           <a:p>
-            <a:pPr algn="ctr" indent="0" marL="0">
+            <a:pPr marL="0" indent="0" algn="ctr">
               <a:buNone/>
             </a:pPr>
             <a:r>
@@ -6242,7 +6252,7 @@
           <a:bodyPr wrap="square" rtlCol="0" anchor="ctr"/>
           <a:lstStyle/>
           <a:p>
-            <a:pPr algn="ctr" indent="0" marL="0">
+            <a:pPr marL="0" indent="0" algn="ctr">
               <a:buNone/>
             </a:pPr>
             <a:r>
@@ -6284,6 +6294,13 @@
             <a:prstDash val="solid"/>
           </a:ln>
         </p:spPr>
+        <p:txBody>
+          <a:bodyPr/>
+          <a:lstStyle/>
+          <a:p>
+            <a:endParaRPr lang="he-IL"/>
+          </a:p>
+        </p:txBody>
       </p:sp>
       <p:sp>
         <p:nvSpPr>
@@ -6304,6 +6321,13 @@
           </a:solidFill>
           <a:ln/>
         </p:spPr>
+        <p:txBody>
+          <a:bodyPr/>
+          <a:lstStyle/>
+          <a:p>
+            <a:endParaRPr lang="he-IL"/>
+          </a:p>
+        </p:txBody>
       </p:sp>
       <p:sp>
         <p:nvSpPr>
@@ -6326,7 +6350,7 @@
           <a:bodyPr wrap="square" rtlCol="0" anchor="ctr"/>
           <a:lstStyle/>
           <a:p>
-            <a:pPr algn="ctr" indent="0" marL="0">
+            <a:pPr marL="0" indent="0" algn="ctr">
               <a:buNone/>
             </a:pPr>
             <a:r>
@@ -6365,7 +6389,7 @@
           <a:bodyPr wrap="square" rtlCol="0" anchor="ctr"/>
           <a:lstStyle/>
           <a:p>
-            <a:pPr algn="ctr" indent="0" marL="0">
+            <a:pPr marL="0" indent="0" algn="ctr">
               <a:buNone/>
             </a:pPr>
             <a:r>
@@ -6404,7 +6428,7 @@
           <a:bodyPr wrap="square" rtlCol="0" anchor="ctr"/>
           <a:lstStyle/>
           <a:p>
-            <a:pPr algn="ctr" indent="0" marL="0">
+            <a:pPr marL="0" indent="0" algn="ctr">
               <a:buNone/>
             </a:pPr>
             <a:r>
@@ -6446,6 +6470,13 @@
             <a:prstDash val="solid"/>
           </a:ln>
         </p:spPr>
+        <p:txBody>
+          <a:bodyPr/>
+          <a:lstStyle/>
+          <a:p>
+            <a:endParaRPr lang="he-IL"/>
+          </a:p>
+        </p:txBody>
       </p:sp>
       <p:sp>
         <p:nvSpPr>
@@ -6466,6 +6497,13 @@
           </a:solidFill>
           <a:ln/>
         </p:spPr>
+        <p:txBody>
+          <a:bodyPr/>
+          <a:lstStyle/>
+          <a:p>
+            <a:endParaRPr lang="he-IL"/>
+          </a:p>
+        </p:txBody>
       </p:sp>
       <p:sp>
         <p:nvSpPr>
@@ -6488,7 +6526,7 @@
           <a:bodyPr wrap="square" rtlCol="0" anchor="ctr"/>
           <a:lstStyle/>
           <a:p>
-            <a:pPr algn="ctr" indent="0" marL="0">
+            <a:pPr marL="0" indent="0" algn="ctr">
               <a:buNone/>
             </a:pPr>
             <a:r>
@@ -6527,7 +6565,7 @@
           <a:bodyPr wrap="square" rtlCol="0" anchor="ctr"/>
           <a:lstStyle/>
           <a:p>
-            <a:pPr algn="ctr" indent="0" marL="0">
+            <a:pPr marL="0" indent="0" algn="ctr">
               <a:buNone/>
             </a:pPr>
             <a:r>
@@ -6566,7 +6604,7 @@
           <a:bodyPr wrap="square" rtlCol="0" anchor="ctr"/>
           <a:lstStyle/>
           <a:p>
-            <a:pPr algn="ctr" indent="0" marL="0">
+            <a:pPr marL="0" indent="0" algn="ctr">
               <a:buNone/>
             </a:pPr>
             <a:r>
@@ -6605,7 +6643,7 @@
           <a:bodyPr wrap="square" rtlCol="0" anchor="ctr"/>
           <a:lstStyle/>
           <a:p>
-            <a:pPr algn="r" indent="0" marL="0">
+            <a:pPr marL="0" indent="0" algn="r">
               <a:buNone/>
             </a:pPr>
             <a:r>
@@ -6625,7 +6663,7 @@
       </p:sp>
       <p:graphicFrame>
         <p:nvGraphicFramePr>
-          <p:cNvPr id="6" name="Table 0"/>
+          <p:cNvPr id="25" name="Table 0"/>
           <p:cNvGraphicFramePr>
             <a:graphicFrameLocks noGrp="1"/>
           </p:cNvGraphicFramePr>
@@ -6639,16 +6677,34 @@
         </p:nvGraphicFramePr>
         <p:xfrm>
           <a:off x="4754880" y="2606040"/>
-          <a:ext cx="4114800" cy="914400"/>
+          <a:ext cx="4114800" cy="1295400"/>
         </p:xfrm>
         <a:graphic>
           <a:graphicData uri="http://schemas.openxmlformats.org/drawingml/2006/table">
             <a:tbl>
               <a:tblPr/>
               <a:tblGrid>
-                <a:gridCol w="2286000"/>
-                <a:gridCol w="914400"/>
-                <a:gridCol w="914400"/>
+                <a:gridCol w="2286000">
+                  <a:extLst>
+                    <a:ext uri="{9D8B030D-6E8A-4147-A177-3AD203B41FA5}">
+                      <a16:colId xmlns:a16="http://schemas.microsoft.com/office/drawing/2014/main" val="20000"/>
+                    </a:ext>
+                  </a:extLst>
+                </a:gridCol>
+                <a:gridCol w="914400">
+                  <a:extLst>
+                    <a:ext uri="{9D8B030D-6E8A-4147-A177-3AD203B41FA5}">
+                      <a16:colId xmlns:a16="http://schemas.microsoft.com/office/drawing/2014/main" val="20001"/>
+                    </a:ext>
+                  </a:extLst>
+                </a:gridCol>
+                <a:gridCol w="914400">
+                  <a:extLst>
+                    <a:ext uri="{9D8B030D-6E8A-4147-A177-3AD203B41FA5}">
+                      <a16:colId xmlns:a16="http://schemas.microsoft.com/office/drawing/2014/main" val="20002"/>
+                    </a:ext>
+                  </a:extLst>
+                </a:gridCol>
               </a:tblGrid>
               <a:tr h="0">
                 <a:tc>
@@ -6656,7 +6712,7 @@
                     <a:bodyPr/>
                     <a:lstStyle/>
                     <a:p>
-                      <a:pPr indent="0" marL="0">
+                      <a:pPr marL="0" indent="0">
                         <a:buNone/>
                       </a:pPr>
                       <a:r>
@@ -6677,7 +6733,7 @@
                       </a:endParaRPr>
                     </a:p>
                   </a:txBody>
-                  <a:tcPr marL="91440" marR="91440" marT="45720" marB="45720">
+                  <a:tcPr>
                     <a:lnL w="6350" cap="flat" cmpd="sng" algn="ctr">
                       <a:solidFill>
                         <a:srgbClr val="1E3A54"/>
@@ -6724,7 +6780,7 @@
                     <a:bodyPr/>
                     <a:lstStyle/>
                     <a:p>
-                      <a:pPr indent="0" marL="0">
+                      <a:pPr marL="0" indent="0">
                         <a:buNone/>
                       </a:pPr>
                       <a:r>
@@ -6745,7 +6801,7 @@
                       </a:endParaRPr>
                     </a:p>
                   </a:txBody>
-                  <a:tcPr marL="91440" marR="91440" marT="45720" marB="45720">
+                  <a:tcPr>
                     <a:lnL w="6350" cap="flat" cmpd="sng" algn="ctr">
                       <a:solidFill>
                         <a:srgbClr val="1E3A54"/>
@@ -6792,7 +6848,7 @@
                     <a:bodyPr/>
                     <a:lstStyle/>
                     <a:p>
-                      <a:pPr indent="0" marL="0">
+                      <a:pPr marL="0" indent="0">
                         <a:buNone/>
                       </a:pPr>
                       <a:r>
@@ -6813,7 +6869,7 @@
                       </a:endParaRPr>
                     </a:p>
                   </a:txBody>
-                  <a:tcPr marL="91440" marR="91440" marT="45720" marB="45720">
+                  <a:tcPr>
                     <a:lnL w="6350" cap="flat" cmpd="sng" algn="ctr">
                       <a:solidFill>
                         <a:srgbClr val="1E3A54"/>
@@ -6855,6 +6911,11 @@
                     </a:solidFill>
                   </a:tcPr>
                 </a:tc>
+                <a:extLst>
+                  <a:ext uri="{0D108BD9-81ED-4DB2-BD59-A6C34878D82A}">
+                    <a16:rowId xmlns:a16="http://schemas.microsoft.com/office/drawing/2014/main" val="10000"/>
+                  </a:ext>
+                </a:extLst>
               </a:tr>
               <a:tr h="0">
                 <a:tc>
@@ -6862,7 +6923,7 @@
                     <a:bodyPr/>
                     <a:lstStyle/>
                     <a:p>
-                      <a:pPr indent="0" marL="0">
+                      <a:pPr marL="0" indent="0">
                         <a:buNone/>
                       </a:pPr>
                       <a:r>
@@ -6883,7 +6944,7 @@
                       </a:endParaRPr>
                     </a:p>
                   </a:txBody>
-                  <a:tcPr marL="91440" marR="91440" marT="45720" marB="45720">
+                  <a:tcPr>
                     <a:lnL w="6350" cap="flat" cmpd="sng" algn="ctr">
                       <a:solidFill>
                         <a:srgbClr val="1E3A54"/>
@@ -6930,7 +6991,7 @@
                     <a:bodyPr/>
                     <a:lstStyle/>
                     <a:p>
-                      <a:pPr indent="0" marL="0">
+                      <a:pPr marL="0" indent="0">
                         <a:buNone/>
                       </a:pPr>
                       <a:r>
@@ -6951,7 +7012,7 @@
                       </a:endParaRPr>
                     </a:p>
                   </a:txBody>
-                  <a:tcPr marL="91440" marR="91440" marT="45720" marB="45720">
+                  <a:tcPr>
                     <a:lnL w="6350" cap="flat" cmpd="sng" algn="ctr">
                       <a:solidFill>
                         <a:srgbClr val="1E3A54"/>
@@ -6998,7 +7059,7 @@
                     <a:bodyPr/>
                     <a:lstStyle/>
                     <a:p>
-                      <a:pPr indent="0" marL="0">
+                      <a:pPr marL="0" indent="0">
                         <a:buNone/>
                       </a:pPr>
                       <a:r>
@@ -7019,7 +7080,7 @@
                       </a:endParaRPr>
                     </a:p>
                   </a:txBody>
-                  <a:tcPr marL="91440" marR="91440" marT="45720" marB="45720">
+                  <a:tcPr>
                     <a:lnL w="6350" cap="flat" cmpd="sng" algn="ctr">
                       <a:solidFill>
                         <a:srgbClr val="1E3A54"/>
@@ -7061,6 +7122,11 @@
                     </a:solidFill>
                   </a:tcPr>
                 </a:tc>
+                <a:extLst>
+                  <a:ext uri="{0D108BD9-81ED-4DB2-BD59-A6C34878D82A}">
+                    <a16:rowId xmlns:a16="http://schemas.microsoft.com/office/drawing/2014/main" val="10001"/>
+                  </a:ext>
+                </a:extLst>
               </a:tr>
               <a:tr h="0">
                 <a:tc>
@@ -7068,7 +7134,7 @@
                     <a:bodyPr/>
                     <a:lstStyle/>
                     <a:p>
-                      <a:pPr indent="0" marL="0">
+                      <a:pPr marL="0" indent="0">
                         <a:buNone/>
                       </a:pPr>
                       <a:r>
@@ -7089,7 +7155,7 @@
                       </a:endParaRPr>
                     </a:p>
                   </a:txBody>
-                  <a:tcPr marL="91440" marR="91440" marT="45720" marB="45720">
+                  <a:tcPr>
                     <a:lnL w="6350" cap="flat" cmpd="sng" algn="ctr">
                       <a:solidFill>
                         <a:srgbClr val="1E3A54"/>
@@ -7136,7 +7202,7 @@
                     <a:bodyPr/>
                     <a:lstStyle/>
                     <a:p>
-                      <a:pPr indent="0" marL="0">
+                      <a:pPr marL="0" indent="0">
                         <a:buNone/>
                       </a:pPr>
                       <a:r>
@@ -7157,7 +7223,7 @@
                       </a:endParaRPr>
                     </a:p>
                   </a:txBody>
-                  <a:tcPr marL="91440" marR="91440" marT="45720" marB="45720">
+                  <a:tcPr>
                     <a:lnL w="6350" cap="flat" cmpd="sng" algn="ctr">
                       <a:solidFill>
                         <a:srgbClr val="1E3A54"/>
@@ -7204,7 +7270,7 @@
                     <a:bodyPr/>
                     <a:lstStyle/>
                     <a:p>
-                      <a:pPr indent="0" marL="0">
+                      <a:pPr marL="0" indent="0">
                         <a:buNone/>
                       </a:pPr>
                       <a:r>
@@ -7225,7 +7291,7 @@
                       </a:endParaRPr>
                     </a:p>
                   </a:txBody>
-                  <a:tcPr marL="91440" marR="91440" marT="45720" marB="45720">
+                  <a:tcPr>
                     <a:lnL w="6350" cap="flat" cmpd="sng" algn="ctr">
                       <a:solidFill>
                         <a:srgbClr val="1E3A54"/>
@@ -7267,6 +7333,11 @@
                     </a:solidFill>
                   </a:tcPr>
                 </a:tc>
+                <a:extLst>
+                  <a:ext uri="{0D108BD9-81ED-4DB2-BD59-A6C34878D82A}">
+                    <a16:rowId xmlns:a16="http://schemas.microsoft.com/office/drawing/2014/main" val="10002"/>
+                  </a:ext>
+                </a:extLst>
               </a:tr>
               <a:tr h="0">
                 <a:tc>
@@ -7274,7 +7345,7 @@
                     <a:bodyPr/>
                     <a:lstStyle/>
                     <a:p>
-                      <a:pPr indent="0" marL="0">
+                      <a:pPr marL="0" indent="0">
                         <a:buNone/>
                       </a:pPr>
                       <a:r>
@@ -7295,7 +7366,7 @@
                       </a:endParaRPr>
                     </a:p>
                   </a:txBody>
-                  <a:tcPr marL="91440" marR="91440" marT="45720" marB="45720">
+                  <a:tcPr>
                     <a:lnL w="6350" cap="flat" cmpd="sng" algn="ctr">
                       <a:solidFill>
                         <a:srgbClr val="1E3A54"/>
@@ -7342,7 +7413,7 @@
                     <a:bodyPr/>
                     <a:lstStyle/>
                     <a:p>
-                      <a:pPr indent="0" marL="0">
+                      <a:pPr marL="0" indent="0">
                         <a:buNone/>
                       </a:pPr>
                       <a:r>
@@ -7363,7 +7434,7 @@
                       </a:endParaRPr>
                     </a:p>
                   </a:txBody>
-                  <a:tcPr marL="91440" marR="91440" marT="45720" marB="45720">
+                  <a:tcPr>
                     <a:lnL w="6350" cap="flat" cmpd="sng" algn="ctr">
                       <a:solidFill>
                         <a:srgbClr val="1E3A54"/>
@@ -7410,7 +7481,7 @@
                     <a:bodyPr/>
                     <a:lstStyle/>
                     <a:p>
-                      <a:pPr indent="0" marL="0">
+                      <a:pPr marL="0" indent="0">
                         <a:buNone/>
                       </a:pPr>
                       <a:r>
@@ -7431,7 +7502,7 @@
                       </a:endParaRPr>
                     </a:p>
                   </a:txBody>
-                  <a:tcPr marL="91440" marR="91440" marT="45720" marB="45720">
+                  <a:tcPr>
                     <a:lnL w="6350" cap="flat" cmpd="sng" algn="ctr">
                       <a:solidFill>
                         <a:srgbClr val="1E3A54"/>
@@ -7473,6 +7544,11 @@
                     </a:solidFill>
                   </a:tcPr>
                 </a:tc>
+                <a:extLst>
+                  <a:ext uri="{0D108BD9-81ED-4DB2-BD59-A6C34878D82A}">
+                    <a16:rowId xmlns:a16="http://schemas.microsoft.com/office/drawing/2014/main" val="10003"/>
+                  </a:ext>
+                </a:extLst>
               </a:tr>
               <a:tr h="0">
                 <a:tc>
@@ -7480,7 +7556,7 @@
                     <a:bodyPr/>
                     <a:lstStyle/>
                     <a:p>
-                      <a:pPr indent="0" marL="0">
+                      <a:pPr marL="0" indent="0">
                         <a:buNone/>
                       </a:pPr>
                       <a:r>
@@ -7501,7 +7577,7 @@
                       </a:endParaRPr>
                     </a:p>
                   </a:txBody>
-                  <a:tcPr marL="91440" marR="91440" marT="45720" marB="45720">
+                  <a:tcPr>
                     <a:lnL w="6350" cap="flat" cmpd="sng" algn="ctr">
                       <a:solidFill>
                         <a:srgbClr val="1E3A54"/>
@@ -7548,7 +7624,7 @@
                     <a:bodyPr/>
                     <a:lstStyle/>
                     <a:p>
-                      <a:pPr indent="0" marL="0">
+                      <a:pPr marL="0" indent="0">
                         <a:buNone/>
                       </a:pPr>
                       <a:r>
@@ -7569,7 +7645,7 @@
                       </a:endParaRPr>
                     </a:p>
                   </a:txBody>
-                  <a:tcPr marL="91440" marR="91440" marT="45720" marB="45720">
+                  <a:tcPr>
                     <a:lnL w="6350" cap="flat" cmpd="sng" algn="ctr">
                       <a:solidFill>
                         <a:srgbClr val="1E3A54"/>
@@ -7616,7 +7692,7 @@
                     <a:bodyPr/>
                     <a:lstStyle/>
                     <a:p>
-                      <a:pPr indent="0" marL="0">
+                      <a:pPr marL="0" indent="0">
                         <a:buNone/>
                       </a:pPr>
                       <a:r>
@@ -7637,7 +7713,7 @@
                       </a:endParaRPr>
                     </a:p>
                   </a:txBody>
-                  <a:tcPr marL="91440" marR="91440" marT="45720" marB="45720">
+                  <a:tcPr>
                     <a:lnL w="6350" cap="flat" cmpd="sng" algn="ctr">
                       <a:solidFill>
                         <a:srgbClr val="1E3A54"/>
@@ -7679,6 +7755,11 @@
                     </a:solidFill>
                   </a:tcPr>
                 </a:tc>
+                <a:extLst>
+                  <a:ext uri="{0D108BD9-81ED-4DB2-BD59-A6C34878D82A}">
+                    <a16:rowId xmlns:a16="http://schemas.microsoft.com/office/drawing/2014/main" val="10004"/>
+                  </a:ext>
+                </a:extLst>
               </a:tr>
             </a:tbl>
           </a:graphicData>
@@ -7705,7 +7786,7 @@
           <a:bodyPr wrap="square" rtlCol="0" anchor="ctr"/>
           <a:lstStyle/>
           <a:p>
-            <a:pPr algn="l" indent="0" marL="0">
+            <a:pPr marL="0" indent="0" algn="l">
               <a:buNone/>
             </a:pPr>
             <a:r>
@@ -7725,7 +7806,7 @@
       </p:sp>
       <p:graphicFrame>
         <p:nvGraphicFramePr>
-          <p:cNvPr id="11" name="Table 1"/>
+          <p:cNvPr id="27" name="Table 1"/>
           <p:cNvGraphicFramePr>
             <a:graphicFrameLocks noGrp="1"/>
           </p:cNvGraphicFramePr>
@@ -7739,16 +7820,34 @@
         </p:nvGraphicFramePr>
         <p:xfrm>
           <a:off x="274320" y="2606040"/>
-          <a:ext cx="4114800" cy="914400"/>
+          <a:ext cx="4114800" cy="1295400"/>
         </p:xfrm>
         <a:graphic>
           <a:graphicData uri="http://schemas.openxmlformats.org/drawingml/2006/table">
             <a:tbl>
               <a:tblPr/>
               <a:tblGrid>
-                <a:gridCol w="2286000"/>
-                <a:gridCol w="914400"/>
-                <a:gridCol w="914400"/>
+                <a:gridCol w="2286000">
+                  <a:extLst>
+                    <a:ext uri="{9D8B030D-6E8A-4147-A177-3AD203B41FA5}">
+                      <a16:colId xmlns:a16="http://schemas.microsoft.com/office/drawing/2014/main" val="20000"/>
+                    </a:ext>
+                  </a:extLst>
+                </a:gridCol>
+                <a:gridCol w="914400">
+                  <a:extLst>
+                    <a:ext uri="{9D8B030D-6E8A-4147-A177-3AD203B41FA5}">
+                      <a16:colId xmlns:a16="http://schemas.microsoft.com/office/drawing/2014/main" val="20001"/>
+                    </a:ext>
+                  </a:extLst>
+                </a:gridCol>
+                <a:gridCol w="914400">
+                  <a:extLst>
+                    <a:ext uri="{9D8B030D-6E8A-4147-A177-3AD203B41FA5}">
+                      <a16:colId xmlns:a16="http://schemas.microsoft.com/office/drawing/2014/main" val="20002"/>
+                    </a:ext>
+                  </a:extLst>
+                </a:gridCol>
               </a:tblGrid>
               <a:tr h="0">
                 <a:tc>
@@ -7756,7 +7855,7 @@
                     <a:bodyPr/>
                     <a:lstStyle/>
                     <a:p>
-                      <a:pPr indent="0" marL="0">
+                      <a:pPr marL="0" indent="0">
                         <a:buNone/>
                       </a:pPr>
                       <a:r>
@@ -7777,7 +7876,7 @@
                       </a:endParaRPr>
                     </a:p>
                   </a:txBody>
-                  <a:tcPr marL="91440" marR="91440" marT="45720" marB="45720">
+                  <a:tcPr>
                     <a:lnL w="6350" cap="flat" cmpd="sng" algn="ctr">
                       <a:solidFill>
                         <a:srgbClr val="1E3A54"/>
@@ -7824,7 +7923,7 @@
                     <a:bodyPr/>
                     <a:lstStyle/>
                     <a:p>
-                      <a:pPr indent="0" marL="0">
+                      <a:pPr marL="0" indent="0">
                         <a:buNone/>
                       </a:pPr>
                       <a:r>
@@ -7845,7 +7944,7 @@
                       </a:endParaRPr>
                     </a:p>
                   </a:txBody>
-                  <a:tcPr marL="91440" marR="91440" marT="45720" marB="45720">
+                  <a:tcPr>
                     <a:lnL w="6350" cap="flat" cmpd="sng" algn="ctr">
                       <a:solidFill>
                         <a:srgbClr val="1E3A54"/>
@@ -7892,7 +7991,7 @@
                     <a:bodyPr/>
                     <a:lstStyle/>
                     <a:p>
-                      <a:pPr indent="0" marL="0">
+                      <a:pPr marL="0" indent="0">
                         <a:buNone/>
                       </a:pPr>
                       <a:r>
@@ -7913,7 +8012,7 @@
                       </a:endParaRPr>
                     </a:p>
                   </a:txBody>
-                  <a:tcPr marL="91440" marR="91440" marT="45720" marB="45720">
+                  <a:tcPr>
                     <a:lnL w="6350" cap="flat" cmpd="sng" algn="ctr">
                       <a:solidFill>
                         <a:srgbClr val="1E3A54"/>
@@ -7955,6 +8054,11 @@
                     </a:solidFill>
                   </a:tcPr>
                 </a:tc>
+                <a:extLst>
+                  <a:ext uri="{0D108BD9-81ED-4DB2-BD59-A6C34878D82A}">
+                    <a16:rowId xmlns:a16="http://schemas.microsoft.com/office/drawing/2014/main" val="10000"/>
+                  </a:ext>
+                </a:extLst>
               </a:tr>
               <a:tr h="0">
                 <a:tc>
@@ -7962,7 +8066,7 @@
                     <a:bodyPr/>
                     <a:lstStyle/>
                     <a:p>
-                      <a:pPr indent="0" marL="0">
+                      <a:pPr marL="0" indent="0">
                         <a:buNone/>
                       </a:pPr>
                       <a:r>
@@ -7983,7 +8087,7 @@
                       </a:endParaRPr>
                     </a:p>
                   </a:txBody>
-                  <a:tcPr marL="91440" marR="91440" marT="45720" marB="45720">
+                  <a:tcPr>
                     <a:lnL w="6350" cap="flat" cmpd="sng" algn="ctr">
                       <a:solidFill>
                         <a:srgbClr val="1E3A54"/>
@@ -8030,7 +8134,7 @@
                     <a:bodyPr/>
                     <a:lstStyle/>
                     <a:p>
-                      <a:pPr indent="0" marL="0">
+                      <a:pPr marL="0" indent="0">
                         <a:buNone/>
                       </a:pPr>
                       <a:r>
@@ -8051,7 +8155,7 @@
                       </a:endParaRPr>
                     </a:p>
                   </a:txBody>
-                  <a:tcPr marL="91440" marR="91440" marT="45720" marB="45720">
+                  <a:tcPr>
                     <a:lnL w="6350" cap="flat" cmpd="sng" algn="ctr">
                       <a:solidFill>
                         <a:srgbClr val="1E3A54"/>
@@ -8098,7 +8202,7 @@
                     <a:bodyPr/>
                     <a:lstStyle/>
                     <a:p>
-                      <a:pPr indent="0" marL="0">
+                      <a:pPr marL="0" indent="0">
                         <a:buNone/>
                       </a:pPr>
                       <a:r>
@@ -8119,7 +8223,7 @@
                       </a:endParaRPr>
                     </a:p>
                   </a:txBody>
-                  <a:tcPr marL="91440" marR="91440" marT="45720" marB="45720">
+                  <a:tcPr>
                     <a:lnL w="6350" cap="flat" cmpd="sng" algn="ctr">
                       <a:solidFill>
                         <a:srgbClr val="1E3A54"/>
@@ -8161,6 +8265,11 @@
                     </a:solidFill>
                   </a:tcPr>
                 </a:tc>
+                <a:extLst>
+                  <a:ext uri="{0D108BD9-81ED-4DB2-BD59-A6C34878D82A}">
+                    <a16:rowId xmlns:a16="http://schemas.microsoft.com/office/drawing/2014/main" val="10001"/>
+                  </a:ext>
+                </a:extLst>
               </a:tr>
               <a:tr h="0">
                 <a:tc>
@@ -8168,7 +8277,7 @@
                     <a:bodyPr/>
                     <a:lstStyle/>
                     <a:p>
-                      <a:pPr indent="0" marL="0">
+                      <a:pPr marL="0" indent="0">
                         <a:buNone/>
                       </a:pPr>
                       <a:r>
@@ -8189,7 +8298,7 @@
                       </a:endParaRPr>
                     </a:p>
                   </a:txBody>
-                  <a:tcPr marL="91440" marR="91440" marT="45720" marB="45720">
+                  <a:tcPr>
                     <a:lnL w="6350" cap="flat" cmpd="sng" algn="ctr">
                       <a:solidFill>
                         <a:srgbClr val="1E3A54"/>
@@ -8236,7 +8345,7 @@
                     <a:bodyPr/>
                     <a:lstStyle/>
                     <a:p>
-                      <a:pPr indent="0" marL="0">
+                      <a:pPr marL="0" indent="0">
                         <a:buNone/>
                       </a:pPr>
                       <a:r>
@@ -8257,7 +8366,7 @@
                       </a:endParaRPr>
                     </a:p>
                   </a:txBody>
-                  <a:tcPr marL="91440" marR="91440" marT="45720" marB="45720">
+                  <a:tcPr>
                     <a:lnL w="6350" cap="flat" cmpd="sng" algn="ctr">
                       <a:solidFill>
                         <a:srgbClr val="1E3A54"/>
@@ -8304,7 +8413,7 @@
                     <a:bodyPr/>
                     <a:lstStyle/>
                     <a:p>
-                      <a:pPr indent="0" marL="0">
+                      <a:pPr marL="0" indent="0">
                         <a:buNone/>
                       </a:pPr>
                       <a:r>
@@ -8325,7 +8434,7 @@
                       </a:endParaRPr>
                     </a:p>
                   </a:txBody>
-                  <a:tcPr marL="91440" marR="91440" marT="45720" marB="45720">
+                  <a:tcPr>
                     <a:lnL w="6350" cap="flat" cmpd="sng" algn="ctr">
                       <a:solidFill>
                         <a:srgbClr val="1E3A54"/>
@@ -8367,6 +8476,11 @@
                     </a:solidFill>
                   </a:tcPr>
                 </a:tc>
+                <a:extLst>
+                  <a:ext uri="{0D108BD9-81ED-4DB2-BD59-A6C34878D82A}">
+                    <a16:rowId xmlns:a16="http://schemas.microsoft.com/office/drawing/2014/main" val="10002"/>
+                  </a:ext>
+                </a:extLst>
               </a:tr>
               <a:tr h="0">
                 <a:tc>
@@ -8374,7 +8488,7 @@
                     <a:bodyPr/>
                     <a:lstStyle/>
                     <a:p>
-                      <a:pPr indent="0" marL="0">
+                      <a:pPr marL="0" indent="0">
                         <a:buNone/>
                       </a:pPr>
                       <a:r>
@@ -8395,7 +8509,7 @@
                       </a:endParaRPr>
                     </a:p>
                   </a:txBody>
-                  <a:tcPr marL="91440" marR="91440" marT="45720" marB="45720">
+                  <a:tcPr>
                     <a:lnL w="6350" cap="flat" cmpd="sng" algn="ctr">
                       <a:solidFill>
                         <a:srgbClr val="1E3A54"/>
@@ -8442,7 +8556,7 @@
                     <a:bodyPr/>
                     <a:lstStyle/>
                     <a:p>
-                      <a:pPr indent="0" marL="0">
+                      <a:pPr marL="0" indent="0">
                         <a:buNone/>
                       </a:pPr>
                       <a:r>
@@ -8463,7 +8577,7 @@
                       </a:endParaRPr>
                     </a:p>
                   </a:txBody>
-                  <a:tcPr marL="91440" marR="91440" marT="45720" marB="45720">
+                  <a:tcPr>
                     <a:lnL w="6350" cap="flat" cmpd="sng" algn="ctr">
                       <a:solidFill>
                         <a:srgbClr val="1E3A54"/>
@@ -8510,7 +8624,7 @@
                     <a:bodyPr/>
                     <a:lstStyle/>
                     <a:p>
-                      <a:pPr indent="0" marL="0">
+                      <a:pPr marL="0" indent="0">
                         <a:buNone/>
                       </a:pPr>
                       <a:r>
@@ -8531,7 +8645,7 @@
                       </a:endParaRPr>
                     </a:p>
                   </a:txBody>
-                  <a:tcPr marL="91440" marR="91440" marT="45720" marB="45720">
+                  <a:tcPr>
                     <a:lnL w="6350" cap="flat" cmpd="sng" algn="ctr">
                       <a:solidFill>
                         <a:srgbClr val="1E3A54"/>
@@ -8573,6 +8687,11 @@
                     </a:solidFill>
                   </a:tcPr>
                 </a:tc>
+                <a:extLst>
+                  <a:ext uri="{0D108BD9-81ED-4DB2-BD59-A6C34878D82A}">
+                    <a16:rowId xmlns:a16="http://schemas.microsoft.com/office/drawing/2014/main" val="10003"/>
+                  </a:ext>
+                </a:extLst>
               </a:tr>
               <a:tr h="0">
                 <a:tc>
@@ -8580,7 +8699,7 @@
                     <a:bodyPr/>
                     <a:lstStyle/>
                     <a:p>
-                      <a:pPr indent="0" marL="0">
+                      <a:pPr marL="0" indent="0">
                         <a:buNone/>
                       </a:pPr>
                       <a:r>
@@ -8601,7 +8720,7 @@
                       </a:endParaRPr>
                     </a:p>
                   </a:txBody>
-                  <a:tcPr marL="91440" marR="91440" marT="45720" marB="45720">
+                  <a:tcPr>
                     <a:lnL w="6350" cap="flat" cmpd="sng" algn="ctr">
                       <a:solidFill>
                         <a:srgbClr val="1E3A54"/>
@@ -8648,7 +8767,7 @@
                     <a:bodyPr/>
                     <a:lstStyle/>
                     <a:p>
-                      <a:pPr indent="0" marL="0">
+                      <a:pPr marL="0" indent="0">
                         <a:buNone/>
                       </a:pPr>
                       <a:r>
@@ -8669,7 +8788,7 @@
                       </a:endParaRPr>
                     </a:p>
                   </a:txBody>
-                  <a:tcPr marL="91440" marR="91440" marT="45720" marB="45720">
+                  <a:tcPr>
                     <a:lnL w="6350" cap="flat" cmpd="sng" algn="ctr">
                       <a:solidFill>
                         <a:srgbClr val="1E3A54"/>
@@ -8716,7 +8835,7 @@
                     <a:bodyPr/>
                     <a:lstStyle/>
                     <a:p>
-                      <a:pPr indent="0" marL="0">
+                      <a:pPr marL="0" indent="0">
                         <a:buNone/>
                       </a:pPr>
                       <a:r>
@@ -8737,7 +8856,7 @@
                       </a:endParaRPr>
                     </a:p>
                   </a:txBody>
-                  <a:tcPr marL="91440" marR="91440" marT="45720" marB="45720">
+                  <a:tcPr>
                     <a:lnL w="6350" cap="flat" cmpd="sng" algn="ctr">
                       <a:solidFill>
                         <a:srgbClr val="1E3A54"/>
@@ -8779,6 +8898,11 @@
                     </a:solidFill>
                   </a:tcPr>
                 </a:tc>
+                <a:extLst>
+                  <a:ext uri="{0D108BD9-81ED-4DB2-BD59-A6C34878D82A}">
+                    <a16:rowId xmlns:a16="http://schemas.microsoft.com/office/drawing/2014/main" val="10004"/>
+                  </a:ext>
+                </a:extLst>
               </a:tr>
             </a:tbl>
           </a:graphicData>
@@ -8786,14 +8910,14 @@
       </p:graphicFrame>
       <p:pic>
         <p:nvPicPr>
-          <p:cNvPr id="28" name="Image 0" descr="C:\Users\roieu\Downloads\akrish project\תרגיל 3\urban_renewal_project\docs\figures\01_target_distribution.png">    </p:cNvPr>
+          <p:cNvPr id="28" name="Image 0" descr="C:\Users\roieu\Downloads\akrish project\תרגיל 3\urban_renewal_project\docs\figures\01_target_distribution.png"/>
           <p:cNvPicPr>
             <a:picLocks noChangeAspect="1"/>
           </p:cNvPicPr>
           <p:nvPr/>
         </p:nvPicPr>
         <p:blipFill>
-          <a:blip r:embed="rId1"/>
+          <a:blip r:embed="rId3"/>
           <a:stretch>
             <a:fillRect/>
           </a:stretch>
@@ -8824,6 +8948,7 @@
         <a:solidFill>
           <a:srgbClr val="0F1923"/>
         </a:solidFill>
+        <a:effectLst/>
       </p:bgPr>
     </p:bg>
     <p:spTree>
@@ -8861,7 +8986,10 @@
         </p:spPr>
         <p:txBody>
           <a:bodyPr/>
-          <a:p/>
+          <a:lstStyle/>
+          <a:p>
+            <a:endParaRPr/>
+          </a:p>
         </p:txBody>
       </p:sp>
       <p:sp>
@@ -8885,7 +9013,7 @@
           <a:bodyPr wrap="square" rtlCol="0" anchor="ctr"/>
           <a:lstStyle/>
           <a:p>
-            <a:pPr rtl="1" algn="r" indent="0" marL="0">
+            <a:pPr marL="0" indent="0" algn="r" rtl="1">
               <a:buNone/>
             </a:pPr>
             <a:r>
@@ -8905,14 +9033,14 @@
       </p:sp>
       <p:pic>
         <p:nvPicPr>
-          <p:cNvPr id="4" name="Image 0" descr="C:\Users\roieu\Downloads\akrish project\תרגיל 3\urban_renewal_project\docs\figures\04_score_vs_margin.png">    </p:cNvPr>
+          <p:cNvPr id="4" name="Image 0" descr="C:\Users\roieu\Downloads\akrish project\תרגיל 3\urban_renewal_project\docs\figures\04_score_vs_margin.png"/>
           <p:cNvPicPr>
             <a:picLocks noChangeAspect="1"/>
           </p:cNvPicPr>
           <p:nvPr/>
         </p:nvPicPr>
         <p:blipFill>
-          <a:blip r:embed="rId1"/>
+          <a:blip r:embed="rId3"/>
           <a:stretch>
             <a:fillRect/>
           </a:stretch>
@@ -8948,7 +9076,7 @@
           <a:bodyPr wrap="square" rtlCol="0" anchor="ctr"/>
           <a:lstStyle/>
           <a:p>
-            <a:pPr algn="ctr" indent="0" marL="0">
+            <a:pPr marL="0" indent="0" algn="ctr">
               <a:buNone/>
             </a:pPr>
             <a:r>
@@ -8968,14 +9096,14 @@
       </p:sp>
       <p:pic>
         <p:nvPicPr>
-          <p:cNvPr id="6" name="Image 1" descr="C:\Users\roieu\Downloads\akrish project\תרגיל 3\urban_renewal_project\docs\figures\02_feasibility_by_city.png">    </p:cNvPr>
+          <p:cNvPr id="6" name="Image 1" descr="C:\Users\roieu\Downloads\akrish project\תרגיל 3\urban_renewal_project\docs\figures\02_feasibility_by_city.png"/>
           <p:cNvPicPr>
             <a:picLocks noChangeAspect="1"/>
           </p:cNvPicPr>
           <p:nvPr/>
         </p:nvPicPr>
         <p:blipFill>
-          <a:blip r:embed="rId2"/>
+          <a:blip r:embed="rId4"/>
           <a:stretch>
             <a:fillRect/>
           </a:stretch>
@@ -9011,7 +9139,7 @@
           <a:bodyPr wrap="square" rtlCol="0" anchor="ctr"/>
           <a:lstStyle/>
           <a:p>
-            <a:pPr algn="ctr" indent="0" marL="0">
+            <a:pPr marL="0" indent="0" algn="ctr">
               <a:buNone/>
             </a:pPr>
             <a:r>
@@ -9050,7 +9178,7 @@
           <a:bodyPr wrap="square" rtlCol="0" anchor="ctr"/>
           <a:lstStyle/>
           <a:p>
-            <a:pPr rtl="1" algn="r" indent="0" marL="0">
+            <a:pPr marL="0" indent="0" algn="r" rtl="1">
               <a:buNone/>
             </a:pPr>
             <a:r>
@@ -9089,7 +9217,7 @@
           <a:bodyPr wrap="square" rtlCol="0" anchor="ctr"/>
           <a:lstStyle/>
           <a:p>
-            <a:pPr rtl="1" algn="r" indent="0" marL="0">
+            <a:pPr marL="0" indent="0" algn="r" rtl="1">
               <a:buNone/>
             </a:pPr>
             <a:r>
@@ -9128,7 +9256,7 @@
           <a:bodyPr wrap="square" rtlCol="0" anchor="ctr"/>
           <a:lstStyle/>
           <a:p>
-            <a:pPr rtl="1" algn="r" indent="0" marL="0">
+            <a:pPr marL="0" indent="0" algn="r" rtl="1">
               <a:buNone/>
             </a:pPr>
             <a:r>
@@ -9167,7 +9295,7 @@
           <a:bodyPr wrap="square" rtlCol="0" anchor="ctr"/>
           <a:lstStyle/>
           <a:p>
-            <a:pPr rtl="1" algn="r" indent="0" marL="0">
+            <a:pPr marL="0" indent="0" algn="r" rtl="1">
               <a:buNone/>
             </a:pPr>
             <a:r>
@@ -9206,7 +9334,7 @@
           <a:bodyPr wrap="square" rtlCol="0" anchor="ctr"/>
           <a:lstStyle/>
           <a:p>
-            <a:pPr rtl="1" algn="r" indent="0" marL="0">
+            <a:pPr marL="0" indent="0" algn="r" rtl="1">
               <a:buNone/>
             </a:pPr>
             <a:r>
@@ -9240,6 +9368,7 @@
         <a:solidFill>
           <a:srgbClr val="0F1923"/>
         </a:solidFill>
+        <a:effectLst/>
       </p:bgPr>
     </p:bg>
     <p:spTree>
@@ -9275,6 +9404,13 @@
           </a:solidFill>
           <a:ln/>
         </p:spPr>
+        <p:txBody>
+          <a:bodyPr/>
+          <a:lstStyle/>
+          <a:p>
+            <a:endParaRPr lang="he-IL"/>
+          </a:p>
+        </p:txBody>
       </p:sp>
       <p:sp>
         <p:nvSpPr>
@@ -9297,7 +9433,7 @@
           <a:bodyPr wrap="square" rtlCol="0" anchor="ctr"/>
           <a:lstStyle/>
           <a:p>
-            <a:pPr rtl="1" algn="r" indent="0" marL="0">
+            <a:pPr marL="0" indent="0" algn="r" rtl="1">
               <a:buNone/>
             </a:pPr>
             <a:r>
@@ -9309,7 +9445,29 @@
                 <a:ea typeface="Calibri" pitchFamily="34" charset="-122"/>
                 <a:cs typeface="Calibri" pitchFamily="34" charset="-120"/>
               </a:rPr>
-              <a:t>SHAP Insights — מה מנהל את ההחלטה?</a:t>
+              <a:t>SHAP Insights </a:t>
+            </a:r>
+            <a:r>
+              <a:rPr lang="en-US" sz="2400" b="1" dirty="0" err="1">
+                <a:solidFill>
+                  <a:srgbClr val="FFFFFF"/>
+                </a:solidFill>
+                <a:latin typeface="Calibri" pitchFamily="34" charset="0"/>
+                <a:ea typeface="Calibri" pitchFamily="34" charset="-122"/>
+                <a:cs typeface="Calibri" pitchFamily="34" charset="-120"/>
+              </a:rPr>
+              <a:t>מה</a:t>
+            </a:r>
+            <a:r>
+              <a:rPr lang="en-US" sz="2400" b="1" dirty="0">
+                <a:solidFill>
+                  <a:srgbClr val="FFFFFF"/>
+                </a:solidFill>
+                <a:latin typeface="Calibri" pitchFamily="34" charset="0"/>
+                <a:ea typeface="Calibri" pitchFamily="34" charset="-122"/>
+                <a:cs typeface="Calibri" pitchFamily="34" charset="-120"/>
+              </a:rPr>
+              <a:t> מנהל את ההחלטה?</a:t>
             </a:r>
             <a:endParaRPr lang="en-US" sz="2400" dirty="0"/>
           </a:p>
@@ -9336,7 +9494,7 @@
           <a:bodyPr wrap="square" rtlCol="0" anchor="ctr"/>
           <a:lstStyle/>
           <a:p>
-            <a:pPr rtl="1" algn="r" indent="0" marL="0">
+            <a:pPr marL="0" indent="0" algn="r" rtl="1">
               <a:buNone/>
             </a:pPr>
             <a:r>
@@ -9373,6 +9531,13 @@
           </a:solidFill>
           <a:ln/>
         </p:spPr>
+        <p:txBody>
+          <a:bodyPr/>
+          <a:lstStyle/>
+          <a:p>
+            <a:endParaRPr lang="he-IL"/>
+          </a:p>
+        </p:txBody>
       </p:sp>
       <p:sp>
         <p:nvSpPr>
@@ -9393,6 +9558,13 @@
           </a:solidFill>
           <a:ln/>
         </p:spPr>
+        <p:txBody>
+          <a:bodyPr/>
+          <a:lstStyle/>
+          <a:p>
+            <a:endParaRPr lang="he-IL"/>
+          </a:p>
+        </p:txBody>
       </p:sp>
       <p:sp>
         <p:nvSpPr>
@@ -9415,7 +9587,7 @@
           <a:bodyPr wrap="square" rtlCol="0" anchor="ctr"/>
           <a:lstStyle/>
           <a:p>
-            <a:pPr algn="l" indent="0" marL="0">
+            <a:pPr marL="0" indent="0" algn="l">
               <a:buNone/>
             </a:pPr>
             <a:r>
@@ -9454,7 +9626,7 @@
           <a:bodyPr wrap="square" rtlCol="0" anchor="ctr"/>
           <a:lstStyle/>
           <a:p>
-            <a:pPr rtl="1" algn="r" indent="0" marL="0">
+            <a:pPr marL="0" indent="0" algn="r" rtl="1">
               <a:buNone/>
             </a:pPr>
             <a:r>
@@ -9491,6 +9663,13 @@
           </a:solidFill>
           <a:ln/>
         </p:spPr>
+        <p:txBody>
+          <a:bodyPr/>
+          <a:lstStyle/>
+          <a:p>
+            <a:endParaRPr lang="he-IL"/>
+          </a:p>
+        </p:txBody>
       </p:sp>
       <p:sp>
         <p:nvSpPr>
@@ -9511,6 +9690,13 @@
           </a:solidFill>
           <a:ln/>
         </p:spPr>
+        <p:txBody>
+          <a:bodyPr/>
+          <a:lstStyle/>
+          <a:p>
+            <a:endParaRPr lang="he-IL"/>
+          </a:p>
+        </p:txBody>
       </p:sp>
       <p:sp>
         <p:nvSpPr>
@@ -9533,7 +9719,7 @@
           <a:bodyPr wrap="square" rtlCol="0" anchor="ctr"/>
           <a:lstStyle/>
           <a:p>
-            <a:pPr algn="l" indent="0" marL="0">
+            <a:pPr marL="0" indent="0" algn="l">
               <a:buNone/>
             </a:pPr>
             <a:r>
@@ -9572,7 +9758,7 @@
           <a:bodyPr wrap="square" rtlCol="0" anchor="ctr"/>
           <a:lstStyle/>
           <a:p>
-            <a:pPr rtl="1" algn="r" indent="0" marL="0">
+            <a:pPr marL="0" indent="0" algn="r" rtl="1">
               <a:buNone/>
             </a:pPr>
             <a:r>
@@ -9609,6 +9795,13 @@
           </a:solidFill>
           <a:ln/>
         </p:spPr>
+        <p:txBody>
+          <a:bodyPr/>
+          <a:lstStyle/>
+          <a:p>
+            <a:endParaRPr lang="he-IL"/>
+          </a:p>
+        </p:txBody>
       </p:sp>
       <p:sp>
         <p:nvSpPr>
@@ -9629,6 +9822,13 @@
           </a:solidFill>
           <a:ln/>
         </p:spPr>
+        <p:txBody>
+          <a:bodyPr/>
+          <a:lstStyle/>
+          <a:p>
+            <a:endParaRPr lang="he-IL"/>
+          </a:p>
+        </p:txBody>
       </p:sp>
       <p:sp>
         <p:nvSpPr>
@@ -9651,7 +9851,7 @@
           <a:bodyPr wrap="square" rtlCol="0" anchor="ctr"/>
           <a:lstStyle/>
           <a:p>
-            <a:pPr algn="l" indent="0" marL="0">
+            <a:pPr marL="0" indent="0" algn="l">
               <a:buNone/>
             </a:pPr>
             <a:r>
@@ -9690,7 +9890,7 @@
           <a:bodyPr wrap="square" rtlCol="0" anchor="ctr"/>
           <a:lstStyle/>
           <a:p>
-            <a:pPr rtl="1" algn="r" indent="0" marL="0">
+            <a:pPr marL="0" indent="0" algn="r" rtl="1">
               <a:buNone/>
             </a:pPr>
             <a:r>
@@ -9727,6 +9927,13 @@
           </a:solidFill>
           <a:ln/>
         </p:spPr>
+        <p:txBody>
+          <a:bodyPr/>
+          <a:lstStyle/>
+          <a:p>
+            <a:endParaRPr lang="he-IL"/>
+          </a:p>
+        </p:txBody>
       </p:sp>
       <p:sp>
         <p:nvSpPr>
@@ -9747,6 +9954,13 @@
           </a:solidFill>
           <a:ln/>
         </p:spPr>
+        <p:txBody>
+          <a:bodyPr/>
+          <a:lstStyle/>
+          <a:p>
+            <a:endParaRPr lang="he-IL"/>
+          </a:p>
+        </p:txBody>
       </p:sp>
       <p:sp>
         <p:nvSpPr>
@@ -9769,7 +9983,7 @@
           <a:bodyPr wrap="square" rtlCol="0" anchor="ctr"/>
           <a:lstStyle/>
           <a:p>
-            <a:pPr algn="l" indent="0" marL="0">
+            <a:pPr marL="0" indent="0" algn="l">
               <a:buNone/>
             </a:pPr>
             <a:r>
@@ -9808,7 +10022,7 @@
           <a:bodyPr wrap="square" rtlCol="0" anchor="ctr"/>
           <a:lstStyle/>
           <a:p>
-            <a:pPr rtl="1" algn="r" indent="0" marL="0">
+            <a:pPr marL="0" indent="0" algn="r" rtl="1">
               <a:buNone/>
             </a:pPr>
             <a:r>
@@ -9845,6 +10059,13 @@
           </a:solidFill>
           <a:ln/>
         </p:spPr>
+        <p:txBody>
+          <a:bodyPr/>
+          <a:lstStyle/>
+          <a:p>
+            <a:endParaRPr lang="he-IL"/>
+          </a:p>
+        </p:txBody>
       </p:sp>
       <p:sp>
         <p:nvSpPr>
@@ -9865,6 +10086,13 @@
           </a:solidFill>
           <a:ln/>
         </p:spPr>
+        <p:txBody>
+          <a:bodyPr/>
+          <a:lstStyle/>
+          <a:p>
+            <a:endParaRPr lang="he-IL"/>
+          </a:p>
+        </p:txBody>
       </p:sp>
       <p:sp>
         <p:nvSpPr>
@@ -9887,7 +10115,7 @@
           <a:bodyPr wrap="square" rtlCol="0" anchor="ctr"/>
           <a:lstStyle/>
           <a:p>
-            <a:pPr algn="l" indent="0" marL="0">
+            <a:pPr marL="0" indent="0" algn="l">
               <a:buNone/>
             </a:pPr>
             <a:r>
@@ -9926,7 +10154,7 @@
           <a:bodyPr wrap="square" rtlCol="0" anchor="ctr"/>
           <a:lstStyle/>
           <a:p>
-            <a:pPr rtl="1" algn="r" indent="0" marL="0">
+            <a:pPr marL="0" indent="0" algn="r" rtl="1">
               <a:buNone/>
             </a:pPr>
             <a:r>
@@ -9963,6 +10191,13 @@
           </a:solidFill>
           <a:ln/>
         </p:spPr>
+        <p:txBody>
+          <a:bodyPr/>
+          <a:lstStyle/>
+          <a:p>
+            <a:endParaRPr lang="he-IL"/>
+          </a:p>
+        </p:txBody>
       </p:sp>
       <p:sp>
         <p:nvSpPr>
@@ -9983,6 +10218,13 @@
           </a:solidFill>
           <a:ln/>
         </p:spPr>
+        <p:txBody>
+          <a:bodyPr/>
+          <a:lstStyle/>
+          <a:p>
+            <a:endParaRPr lang="he-IL"/>
+          </a:p>
+        </p:txBody>
       </p:sp>
       <p:sp>
         <p:nvSpPr>
@@ -10005,7 +10247,7 @@
           <a:bodyPr wrap="square" rtlCol="0" anchor="ctr"/>
           <a:lstStyle/>
           <a:p>
-            <a:pPr algn="l" indent="0" marL="0">
+            <a:pPr marL="0" indent="0" algn="l">
               <a:buNone/>
             </a:pPr>
             <a:r>
@@ -10044,7 +10286,7 @@
           <a:bodyPr wrap="square" rtlCol="0" anchor="ctr"/>
           <a:lstStyle/>
           <a:p>
-            <a:pPr rtl="1" algn="r" indent="0" marL="0">
+            <a:pPr marL="0" indent="0" algn="r" rtl="1">
               <a:buNone/>
             </a:pPr>
             <a:r>
@@ -10081,6 +10323,13 @@
           </a:solidFill>
           <a:ln/>
         </p:spPr>
+        <p:txBody>
+          <a:bodyPr/>
+          <a:lstStyle/>
+          <a:p>
+            <a:endParaRPr lang="he-IL"/>
+          </a:p>
+        </p:txBody>
       </p:sp>
       <p:sp>
         <p:nvSpPr>
@@ -10101,6 +10350,13 @@
           </a:solidFill>
           <a:ln/>
         </p:spPr>
+        <p:txBody>
+          <a:bodyPr/>
+          <a:lstStyle/>
+          <a:p>
+            <a:endParaRPr lang="he-IL"/>
+          </a:p>
+        </p:txBody>
       </p:sp>
       <p:sp>
         <p:nvSpPr>
@@ -10123,7 +10379,7 @@
           <a:bodyPr wrap="square" rtlCol="0" anchor="ctr"/>
           <a:lstStyle/>
           <a:p>
-            <a:pPr algn="l" indent="0" marL="0">
+            <a:pPr marL="0" indent="0" algn="l">
               <a:buNone/>
             </a:pPr>
             <a:r>
@@ -10162,7 +10418,7 @@
           <a:bodyPr wrap="square" rtlCol="0" anchor="ctr"/>
           <a:lstStyle/>
           <a:p>
-            <a:pPr rtl="1" algn="r" indent="0" marL="0">
+            <a:pPr marL="0" indent="0" algn="r" rtl="1">
               <a:buNone/>
             </a:pPr>
             <a:r>
@@ -10199,6 +10455,13 @@
           </a:solidFill>
           <a:ln/>
         </p:spPr>
+        <p:txBody>
+          <a:bodyPr/>
+          <a:lstStyle/>
+          <a:p>
+            <a:endParaRPr lang="he-IL"/>
+          </a:p>
+        </p:txBody>
       </p:sp>
       <p:sp>
         <p:nvSpPr>
@@ -10219,6 +10482,13 @@
           </a:solidFill>
           <a:ln/>
         </p:spPr>
+        <p:txBody>
+          <a:bodyPr/>
+          <a:lstStyle/>
+          <a:p>
+            <a:endParaRPr lang="he-IL"/>
+          </a:p>
+        </p:txBody>
       </p:sp>
       <p:sp>
         <p:nvSpPr>
@@ -10241,7 +10511,7 @@
           <a:bodyPr wrap="square" rtlCol="0" anchor="ctr"/>
           <a:lstStyle/>
           <a:p>
-            <a:pPr algn="l" indent="0" marL="0">
+            <a:pPr marL="0" indent="0" algn="l">
               <a:buNone/>
             </a:pPr>
             <a:r>
@@ -10280,7 +10550,7 @@
           <a:bodyPr wrap="square" rtlCol="0" anchor="ctr"/>
           <a:lstStyle/>
           <a:p>
-            <a:pPr rtl="1" algn="r" indent="0" marL="0">
+            <a:pPr marL="0" indent="0" algn="r" rtl="1">
               <a:buNone/>
             </a:pPr>
             <a:r>
@@ -10317,6 +10587,13 @@
           </a:solidFill>
           <a:ln/>
         </p:spPr>
+        <p:txBody>
+          <a:bodyPr/>
+          <a:lstStyle/>
+          <a:p>
+            <a:endParaRPr lang="he-IL"/>
+          </a:p>
+        </p:txBody>
       </p:sp>
       <p:sp>
         <p:nvSpPr>
@@ -10337,6 +10614,13 @@
           </a:solidFill>
           <a:ln/>
         </p:spPr>
+        <p:txBody>
+          <a:bodyPr/>
+          <a:lstStyle/>
+          <a:p>
+            <a:endParaRPr lang="he-IL"/>
+          </a:p>
+        </p:txBody>
       </p:sp>
       <p:sp>
         <p:nvSpPr>
@@ -10359,7 +10643,7 @@
           <a:bodyPr wrap="square" rtlCol="0" anchor="ctr"/>
           <a:lstStyle/>
           <a:p>
-            <a:pPr algn="l" indent="0" marL="0">
+            <a:pPr marL="0" indent="0" algn="l">
               <a:buNone/>
             </a:pPr>
             <a:r>
@@ -10398,7 +10682,7 @@
           <a:bodyPr wrap="square" rtlCol="0" anchor="ctr"/>
           <a:lstStyle/>
           <a:p>
-            <a:pPr rtl="1" algn="r" indent="0" marL="0">
+            <a:pPr marL="0" indent="0" algn="r" rtl="1">
               <a:buNone/>
             </a:pPr>
             <a:r>
@@ -10435,6 +10719,13 @@
           </a:solidFill>
           <a:ln/>
         </p:spPr>
+        <p:txBody>
+          <a:bodyPr/>
+          <a:lstStyle/>
+          <a:p>
+            <a:endParaRPr lang="he-IL"/>
+          </a:p>
+        </p:txBody>
       </p:sp>
       <p:sp>
         <p:nvSpPr>
@@ -10455,6 +10746,13 @@
           </a:solidFill>
           <a:ln/>
         </p:spPr>
+        <p:txBody>
+          <a:bodyPr/>
+          <a:lstStyle/>
+          <a:p>
+            <a:endParaRPr lang="he-IL"/>
+          </a:p>
+        </p:txBody>
       </p:sp>
       <p:sp>
         <p:nvSpPr>
@@ -10477,7 +10775,7 @@
           <a:bodyPr wrap="square" rtlCol="0" anchor="ctr"/>
           <a:lstStyle/>
           <a:p>
-            <a:pPr algn="l" indent="0" marL="0">
+            <a:pPr marL="0" indent="0" algn="l">
               <a:buNone/>
             </a:pPr>
             <a:r>
@@ -10516,7 +10814,7 @@
           <a:bodyPr wrap="square" rtlCol="0" anchor="ctr"/>
           <a:lstStyle/>
           <a:p>
-            <a:pPr algn="ctr" indent="0" marL="0">
+            <a:pPr marL="0" indent="0" algn="ctr">
               <a:buNone/>
             </a:pPr>
             <a:r>
@@ -10550,6 +10848,7 @@
         <a:solidFill>
           <a:srgbClr val="0F1923"/>
         </a:solidFill>
+        <a:effectLst/>
       </p:bgPr>
     </p:bg>
     <p:spTree>
@@ -10585,6 +10884,13 @@
           </a:solidFill>
           <a:ln/>
         </p:spPr>
+        <p:txBody>
+          <a:bodyPr/>
+          <a:lstStyle/>
+          <a:p>
+            <a:endParaRPr lang="he-IL"/>
+          </a:p>
+        </p:txBody>
       </p:sp>
       <p:sp>
         <p:nvSpPr>
@@ -10607,7 +10913,7 @@
           <a:bodyPr wrap="square" rtlCol="0" anchor="ctr"/>
           <a:lstStyle/>
           <a:p>
-            <a:pPr rtl="1" algn="r" indent="0" marL="0">
+            <a:pPr marL="0" indent="0" algn="r" rtl="1">
               <a:buNone/>
             </a:pPr>
             <a:r>
@@ -10649,6 +10955,13 @@
             <a:prstDash val="solid"/>
           </a:ln>
         </p:spPr>
+        <p:txBody>
+          <a:bodyPr/>
+          <a:lstStyle/>
+          <a:p>
+            <a:endParaRPr lang="he-IL"/>
+          </a:p>
+        </p:txBody>
       </p:sp>
       <p:sp>
         <p:nvSpPr>
@@ -10671,7 +10984,7 @@
           <a:bodyPr wrap="square" rtlCol="0" anchor="ctr"/>
           <a:lstStyle/>
           <a:p>
-            <a:pPr algn="ctr" indent="0" marL="0">
+            <a:pPr marL="0" indent="0" algn="ctr">
               <a:buNone/>
             </a:pPr>
             <a:r>
@@ -10707,7 +11020,7 @@
           <a:bodyPr wrap="square" rtlCol="0" anchor="ctr"/>
           <a:lstStyle/>
           <a:p>
-            <a:pPr algn="l" indent="0" marL="0">
+            <a:pPr marL="0" indent="0" algn="l">
               <a:buNone/>
             </a:pPr>
             <a:r>
@@ -10746,7 +11059,7 @@
           <a:bodyPr wrap="square" rtlCol="0" anchor="ctr"/>
           <a:lstStyle/>
           <a:p>
-            <a:pPr algn="l" indent="0" marL="0">
+            <a:pPr marL="0" indent="0" algn="l">
               <a:buNone/>
             </a:pPr>
             <a:r>
@@ -10788,6 +11101,13 @@
             <a:prstDash val="solid"/>
           </a:ln>
         </p:spPr>
+        <p:txBody>
+          <a:bodyPr/>
+          <a:lstStyle/>
+          <a:p>
+            <a:endParaRPr lang="he-IL"/>
+          </a:p>
+        </p:txBody>
       </p:sp>
       <p:sp>
         <p:nvSpPr>
@@ -10810,7 +11130,7 @@
           <a:bodyPr wrap="square" rtlCol="0" anchor="ctr"/>
           <a:lstStyle/>
           <a:p>
-            <a:pPr algn="ctr" indent="0" marL="0">
+            <a:pPr marL="0" indent="0" algn="ctr">
               <a:buNone/>
             </a:pPr>
             <a:r>
@@ -10846,7 +11166,7 @@
           <a:bodyPr wrap="square" rtlCol="0" anchor="ctr"/>
           <a:lstStyle/>
           <a:p>
-            <a:pPr algn="l" indent="0" marL="0">
+            <a:pPr marL="0" indent="0" algn="l">
               <a:buNone/>
             </a:pPr>
             <a:r>
@@ -10885,7 +11205,7 @@
           <a:bodyPr wrap="square" rtlCol="0" anchor="ctr"/>
           <a:lstStyle/>
           <a:p>
-            <a:pPr algn="l" indent="0" marL="0">
+            <a:pPr marL="0" indent="0" algn="l">
               <a:buNone/>
             </a:pPr>
             <a:r>
@@ -10927,6 +11247,13 @@
             <a:prstDash val="solid"/>
           </a:ln>
         </p:spPr>
+        <p:txBody>
+          <a:bodyPr/>
+          <a:lstStyle/>
+          <a:p>
+            <a:endParaRPr lang="he-IL"/>
+          </a:p>
+        </p:txBody>
       </p:sp>
       <p:sp>
         <p:nvSpPr>
@@ -10949,7 +11276,7 @@
           <a:bodyPr wrap="square" rtlCol="0" anchor="ctr"/>
           <a:lstStyle/>
           <a:p>
-            <a:pPr algn="ctr" indent="0" marL="0">
+            <a:pPr marL="0" indent="0" algn="ctr">
               <a:buNone/>
             </a:pPr>
             <a:r>
@@ -10985,7 +11312,7 @@
           <a:bodyPr wrap="square" rtlCol="0" anchor="ctr"/>
           <a:lstStyle/>
           <a:p>
-            <a:pPr algn="l" indent="0" marL="0">
+            <a:pPr marL="0" indent="0" algn="l">
               <a:buNone/>
             </a:pPr>
             <a:r>
@@ -11024,7 +11351,7 @@
           <a:bodyPr wrap="square" rtlCol="0" anchor="ctr"/>
           <a:lstStyle/>
           <a:p>
-            <a:pPr algn="l" indent="0" marL="0">
+            <a:pPr marL="0" indent="0" algn="l">
               <a:buNone/>
             </a:pPr>
             <a:r>
@@ -11066,6 +11393,13 @@
             <a:prstDash val="solid"/>
           </a:ln>
         </p:spPr>
+        <p:txBody>
+          <a:bodyPr/>
+          <a:lstStyle/>
+          <a:p>
+            <a:endParaRPr lang="he-IL"/>
+          </a:p>
+        </p:txBody>
       </p:sp>
       <p:sp>
         <p:nvSpPr>
@@ -11088,7 +11422,7 @@
           <a:bodyPr wrap="square" rtlCol="0" anchor="ctr"/>
           <a:lstStyle/>
           <a:p>
-            <a:pPr algn="ctr" indent="0" marL="0">
+            <a:pPr marL="0" indent="0" algn="ctr">
               <a:buNone/>
             </a:pPr>
             <a:r>
@@ -11124,7 +11458,7 @@
           <a:bodyPr wrap="square" rtlCol="0" anchor="ctr"/>
           <a:lstStyle/>
           <a:p>
-            <a:pPr algn="l" indent="0" marL="0">
+            <a:pPr marL="0" indent="0" algn="l">
               <a:buNone/>
             </a:pPr>
             <a:r>
@@ -11163,7 +11497,7 @@
           <a:bodyPr wrap="square" rtlCol="0" anchor="ctr"/>
           <a:lstStyle/>
           <a:p>
-            <a:pPr algn="l" indent="0" marL="0">
+            <a:pPr marL="0" indent="0" algn="l">
               <a:buNone/>
             </a:pPr>
             <a:r>
@@ -11202,7 +11536,7 @@
           <a:bodyPr wrap="square" rtlCol="0" anchor="ctr"/>
           <a:lstStyle/>
           <a:p>
-            <a:pPr rtl="1" algn="r" indent="0" marL="0">
+            <a:pPr marL="0" indent="0" algn="r" rtl="1">
               <a:buNone/>
             </a:pPr>
             <a:r>
@@ -11239,6 +11573,13 @@
           </a:solidFill>
           <a:ln/>
         </p:spPr>
+        <p:txBody>
+          <a:bodyPr/>
+          <a:lstStyle/>
+          <a:p>
+            <a:endParaRPr lang="he-IL"/>
+          </a:p>
+        </p:txBody>
       </p:sp>
       <p:sp>
         <p:nvSpPr>
@@ -11261,7 +11602,7 @@
           <a:bodyPr wrap="square" rtlCol="0" anchor="ctr"/>
           <a:lstStyle/>
           <a:p>
-            <a:pPr rtl="1" algn="r" indent="0" marL="0">
+            <a:pPr marL="0" indent="0" algn="r" rtl="1">
               <a:buNone/>
             </a:pPr>
             <a:r>
@@ -11298,6 +11639,13 @@
           </a:solidFill>
           <a:ln/>
         </p:spPr>
+        <p:txBody>
+          <a:bodyPr/>
+          <a:lstStyle/>
+          <a:p>
+            <a:endParaRPr lang="he-IL"/>
+          </a:p>
+        </p:txBody>
       </p:sp>
       <p:sp>
         <p:nvSpPr>
@@ -11320,7 +11668,7 @@
           <a:bodyPr wrap="square" rtlCol="0" anchor="ctr"/>
           <a:lstStyle/>
           <a:p>
-            <a:pPr rtl="1" algn="r" indent="0" marL="0">
+            <a:pPr marL="0" indent="0" algn="r" rtl="1">
               <a:buNone/>
             </a:pPr>
             <a:r>
@@ -11357,6 +11705,13 @@
           </a:solidFill>
           <a:ln/>
         </p:spPr>
+        <p:txBody>
+          <a:bodyPr/>
+          <a:lstStyle/>
+          <a:p>
+            <a:endParaRPr lang="he-IL"/>
+          </a:p>
+        </p:txBody>
       </p:sp>
       <p:sp>
         <p:nvSpPr>
@@ -11379,7 +11734,7 @@
           <a:bodyPr wrap="square" rtlCol="0" anchor="ctr"/>
           <a:lstStyle/>
           <a:p>
-            <a:pPr rtl="1" algn="r" indent="0" marL="0">
+            <a:pPr marL="0" indent="0" algn="r" rtl="1">
               <a:buNone/>
             </a:pPr>
             <a:r>
@@ -11416,6 +11771,13 @@
           </a:solidFill>
           <a:ln/>
         </p:spPr>
+        <p:txBody>
+          <a:bodyPr/>
+          <a:lstStyle/>
+          <a:p>
+            <a:endParaRPr lang="he-IL"/>
+          </a:p>
+        </p:txBody>
       </p:sp>
       <p:sp>
         <p:nvSpPr>
@@ -11438,7 +11800,7 @@
           <a:bodyPr wrap="square" rtlCol="0" anchor="ctr"/>
           <a:lstStyle/>
           <a:p>
-            <a:pPr rtl="1" algn="r" indent="0" marL="0">
+            <a:pPr marL="0" indent="0" algn="r" rtl="1">
               <a:buNone/>
             </a:pPr>
             <a:r>
@@ -11475,6 +11837,13 @@
           </a:solidFill>
           <a:ln/>
         </p:spPr>
+        <p:txBody>
+          <a:bodyPr/>
+          <a:lstStyle/>
+          <a:p>
+            <a:endParaRPr lang="he-IL"/>
+          </a:p>
+        </p:txBody>
       </p:sp>
       <p:sp>
         <p:nvSpPr>
@@ -11497,7 +11866,7 @@
           <a:bodyPr wrap="square" rtlCol="0" anchor="ctr"/>
           <a:lstStyle/>
           <a:p>
-            <a:pPr rtl="1" algn="r" indent="0" marL="0">
+            <a:pPr marL="0" indent="0" algn="r" rtl="1">
               <a:buNone/>
             </a:pPr>
             <a:r>
@@ -11536,7 +11905,7 @@
           <a:bodyPr wrap="square" rtlCol="0" anchor="ctr"/>
           <a:lstStyle/>
           <a:p>
-            <a:pPr algn="ctr" indent="0" marL="0">
+            <a:pPr marL="0" indent="0" algn="ctr">
               <a:buNone/>
             </a:pPr>
             <a:r>
@@ -11855,4 +12224,319 @@
     </a:ext>
   </a:extLst>
 </a:theme>
+</file>
+
+<file path=ppt/theme/theme2.xml><?xml version="1.0" encoding="utf-8"?>
+<a:theme xmlns:a="http://schemas.openxmlformats.org/drawingml/2006/main" name="ערכת נושא Office">
+  <a:themeElements>
+    <a:clrScheme name="Office">
+      <a:dk1>
+        <a:sysClr val="windowText" lastClr="000000"/>
+      </a:dk1>
+      <a:lt1>
+        <a:sysClr val="window" lastClr="FFFFFF"/>
+      </a:lt1>
+      <a:dk2>
+        <a:srgbClr val="0E2841"/>
+      </a:dk2>
+      <a:lt2>
+        <a:srgbClr val="E8E8E8"/>
+      </a:lt2>
+      <a:accent1>
+        <a:srgbClr val="156082"/>
+      </a:accent1>
+      <a:accent2>
+        <a:srgbClr val="E97132"/>
+      </a:accent2>
+      <a:accent3>
+        <a:srgbClr val="196B24"/>
+      </a:accent3>
+      <a:accent4>
+        <a:srgbClr val="0F9ED5"/>
+      </a:accent4>
+      <a:accent5>
+        <a:srgbClr val="A02B93"/>
+      </a:accent5>
+      <a:accent6>
+        <a:srgbClr val="4EA72E"/>
+      </a:accent6>
+      <a:hlink>
+        <a:srgbClr val="467886"/>
+      </a:hlink>
+      <a:folHlink>
+        <a:srgbClr val="96607D"/>
+      </a:folHlink>
+    </a:clrScheme>
+    <a:fontScheme name="Office">
+      <a:majorFont>
+        <a:latin typeface="Aptos Display" panose="02110004020202020204"/>
+        <a:ea typeface=""/>
+        <a:cs typeface=""/>
+        <a:font script="Jpan" typeface="游ゴシック Light"/>
+        <a:font script="Hang" typeface="맑은 고딕"/>
+        <a:font script="Hans" typeface="等线 Light"/>
+        <a:font script="Hant" typeface="新細明體"/>
+        <a:font script="Arab" typeface="Times New Roman"/>
+        <a:font script="Hebr" typeface="Times New Roman"/>
+        <a:font script="Thai" typeface="Angsana New"/>
+        <a:font script="Ethi" typeface="Nyala"/>
+        <a:font script="Beng" typeface="Vrinda"/>
+        <a:font script="Gujr" typeface="Shruti"/>
+        <a:font script="Khmr" typeface="MoolBoran"/>
+        <a:font script="Knda" typeface="Tunga"/>
+        <a:font script="Guru" typeface="Raavi"/>
+        <a:font script="Cans" typeface="Euphemia"/>
+        <a:font script="Cher" typeface="Plantagenet Cherokee"/>
+        <a:font script="Yiii" typeface="Microsoft Yi Baiti"/>
+        <a:font script="Tibt" typeface="Microsoft Himalaya"/>
+        <a:font script="Thaa" typeface="MV Boli"/>
+        <a:font script="Deva" typeface="Mangal"/>
+        <a:font script="Telu" typeface="Gautami"/>
+        <a:font script="Taml" typeface="Latha"/>
+        <a:font script="Syrc" typeface="Estrangelo Edessa"/>
+        <a:font script="Orya" typeface="Kalinga"/>
+        <a:font script="Mlym" typeface="Kartika"/>
+        <a:font script="Laoo" typeface="DokChampa"/>
+        <a:font script="Sinh" typeface="Iskoola Pota"/>
+        <a:font script="Mong" typeface="Mongolian Baiti"/>
+        <a:font script="Viet" typeface="Times New Roman"/>
+        <a:font script="Uigh" typeface="Microsoft Uighur"/>
+        <a:font script="Geor" typeface="Sylfaen"/>
+        <a:font script="Armn" typeface="Arial"/>
+        <a:font script="Bugi" typeface="Leelawadee UI"/>
+        <a:font script="Bopo" typeface="Microsoft JhengHei"/>
+        <a:font script="Java" typeface="Javanese Text"/>
+        <a:font script="Lisu" typeface="Segoe UI"/>
+        <a:font script="Mymr" typeface="Myanmar Text"/>
+        <a:font script="Nkoo" typeface="Ebrima"/>
+        <a:font script="Olck" typeface="Nirmala UI"/>
+        <a:font script="Osma" typeface="Ebrima"/>
+        <a:font script="Phag" typeface="Phagspa"/>
+        <a:font script="Syrn" typeface="Estrangelo Edessa"/>
+        <a:font script="Syrj" typeface="Estrangelo Edessa"/>
+        <a:font script="Syre" typeface="Estrangelo Edessa"/>
+        <a:font script="Sora" typeface="Nirmala UI"/>
+        <a:font script="Tale" typeface="Microsoft Tai Le"/>
+        <a:font script="Talu" typeface="Microsoft New Tai Lue"/>
+        <a:font script="Tfng" typeface="Ebrima"/>
+      </a:majorFont>
+      <a:minorFont>
+        <a:latin typeface="Aptos" panose="02110004020202020204"/>
+        <a:ea typeface=""/>
+        <a:cs typeface=""/>
+        <a:font script="Jpan" typeface="游ゴシック"/>
+        <a:font script="Hang" typeface="맑은 고딕"/>
+        <a:font script="Hans" typeface="等线"/>
+        <a:font script="Hant" typeface="新細明體"/>
+        <a:font script="Arab" typeface="Arial"/>
+        <a:font script="Hebr" typeface="Arial"/>
+        <a:font script="Thai" typeface="Cordia New"/>
+        <a:font script="Ethi" typeface="Nyala"/>
+        <a:font script="Beng" typeface="Vrinda"/>
+        <a:font script="Gujr" typeface="Shruti"/>
+        <a:font script="Khmr" typeface="DaunPenh"/>
+        <a:font script="Knda" typeface="Tunga"/>
+        <a:font script="Guru" typeface="Raavi"/>
+        <a:font script="Cans" typeface="Euphemia"/>
+        <a:font script="Cher" typeface="Plantagenet Cherokee"/>
+        <a:font script="Yiii" typeface="Microsoft Yi Baiti"/>
+        <a:font script="Tibt" typeface="Microsoft Himalaya"/>
+        <a:font script="Thaa" typeface="MV Boli"/>
+        <a:font script="Deva" typeface="Mangal"/>
+        <a:font script="Telu" typeface="Gautami"/>
+        <a:font script="Taml" typeface="Latha"/>
+        <a:font script="Syrc" typeface="Estrangelo Edessa"/>
+        <a:font script="Orya" typeface="Kalinga"/>
+        <a:font script="Mlym" typeface="Kartika"/>
+        <a:font script="Laoo" typeface="DokChampa"/>
+        <a:font script="Sinh" typeface="Iskoola Pota"/>
+        <a:font script="Mong" typeface="Mongolian Baiti"/>
+        <a:font script="Viet" typeface="Arial"/>
+        <a:font script="Uigh" typeface="Microsoft Uighur"/>
+        <a:font script="Geor" typeface="Sylfaen"/>
+        <a:font script="Armn" typeface="Arial"/>
+        <a:font script="Bugi" typeface="Leelawadee UI"/>
+        <a:font script="Bopo" typeface="Microsoft JhengHei"/>
+        <a:font script="Java" typeface="Javanese Text"/>
+        <a:font script="Lisu" typeface="Segoe UI"/>
+        <a:font script="Mymr" typeface="Myanmar Text"/>
+        <a:font script="Nkoo" typeface="Ebrima"/>
+        <a:font script="Olck" typeface="Nirmala UI"/>
+        <a:font script="Osma" typeface="Ebrima"/>
+        <a:font script="Phag" typeface="Phagspa"/>
+        <a:font script="Syrn" typeface="Estrangelo Edessa"/>
+        <a:font script="Syrj" typeface="Estrangelo Edessa"/>
+        <a:font script="Syre" typeface="Estrangelo Edessa"/>
+        <a:font script="Sora" typeface="Nirmala UI"/>
+        <a:font script="Tale" typeface="Microsoft Tai Le"/>
+        <a:font script="Talu" typeface="Microsoft New Tai Lue"/>
+        <a:font script="Tfng" typeface="Ebrima"/>
+      </a:minorFont>
+    </a:fontScheme>
+    <a:fmtScheme name="Office">
+      <a:fillStyleLst>
+        <a:solidFill>
+          <a:schemeClr val="phClr"/>
+        </a:solidFill>
+        <a:gradFill rotWithShape="1">
+          <a:gsLst>
+            <a:gs pos="0">
+              <a:schemeClr val="phClr">
+                <a:lumMod val="110000"/>
+                <a:satMod val="105000"/>
+                <a:tint val="67000"/>
+              </a:schemeClr>
+            </a:gs>
+            <a:gs pos="50000">
+              <a:schemeClr val="phClr">
+                <a:lumMod val="105000"/>
+                <a:satMod val="103000"/>
+                <a:tint val="73000"/>
+              </a:schemeClr>
+            </a:gs>
+            <a:gs pos="100000">
+              <a:schemeClr val="phClr">
+                <a:lumMod val="105000"/>
+                <a:satMod val="109000"/>
+                <a:tint val="81000"/>
+              </a:schemeClr>
+            </a:gs>
+          </a:gsLst>
+          <a:lin ang="5400000" scaled="0"/>
+        </a:gradFill>
+        <a:gradFill rotWithShape="1">
+          <a:gsLst>
+            <a:gs pos="0">
+              <a:schemeClr val="phClr">
+                <a:satMod val="103000"/>
+                <a:lumMod val="102000"/>
+                <a:tint val="94000"/>
+              </a:schemeClr>
+            </a:gs>
+            <a:gs pos="50000">
+              <a:schemeClr val="phClr">
+                <a:satMod val="110000"/>
+                <a:lumMod val="100000"/>
+                <a:shade val="100000"/>
+              </a:schemeClr>
+            </a:gs>
+            <a:gs pos="100000">
+              <a:schemeClr val="phClr">
+                <a:lumMod val="99000"/>
+                <a:satMod val="120000"/>
+                <a:shade val="78000"/>
+              </a:schemeClr>
+            </a:gs>
+          </a:gsLst>
+          <a:lin ang="5400000" scaled="0"/>
+        </a:gradFill>
+      </a:fillStyleLst>
+      <a:lnStyleLst>
+        <a:ln w="12700" cap="flat" cmpd="sng" algn="ctr">
+          <a:solidFill>
+            <a:schemeClr val="phClr"/>
+          </a:solidFill>
+          <a:prstDash val="solid"/>
+          <a:miter lim="800000"/>
+        </a:ln>
+        <a:ln w="19050" cap="flat" cmpd="sng" algn="ctr">
+          <a:solidFill>
+            <a:schemeClr val="phClr"/>
+          </a:solidFill>
+          <a:prstDash val="solid"/>
+          <a:miter lim="800000"/>
+        </a:ln>
+        <a:ln w="25400" cap="flat" cmpd="sng" algn="ctr">
+          <a:solidFill>
+            <a:schemeClr val="phClr"/>
+          </a:solidFill>
+          <a:prstDash val="solid"/>
+          <a:miter lim="800000"/>
+        </a:ln>
+      </a:lnStyleLst>
+      <a:effectStyleLst>
+        <a:effectStyle>
+          <a:effectLst/>
+        </a:effectStyle>
+        <a:effectStyle>
+          <a:effectLst/>
+        </a:effectStyle>
+        <a:effectStyle>
+          <a:effectLst>
+            <a:outerShdw blurRad="57150" dist="19050" dir="5400000" algn="ctr" rotWithShape="0">
+              <a:srgbClr val="000000">
+                <a:alpha val="63000"/>
+              </a:srgbClr>
+            </a:outerShdw>
+          </a:effectLst>
+        </a:effectStyle>
+      </a:effectStyleLst>
+      <a:bgFillStyleLst>
+        <a:solidFill>
+          <a:schemeClr val="phClr"/>
+        </a:solidFill>
+        <a:solidFill>
+          <a:schemeClr val="phClr">
+            <a:tint val="95000"/>
+            <a:satMod val="170000"/>
+          </a:schemeClr>
+        </a:solidFill>
+        <a:gradFill rotWithShape="1">
+          <a:gsLst>
+            <a:gs pos="0">
+              <a:schemeClr val="phClr">
+                <a:tint val="93000"/>
+                <a:satMod val="150000"/>
+                <a:shade val="98000"/>
+                <a:lumMod val="102000"/>
+              </a:schemeClr>
+            </a:gs>
+            <a:gs pos="50000">
+              <a:schemeClr val="phClr">
+                <a:tint val="98000"/>
+                <a:satMod val="130000"/>
+                <a:shade val="90000"/>
+                <a:lumMod val="103000"/>
+              </a:schemeClr>
+            </a:gs>
+            <a:gs pos="100000">
+              <a:schemeClr val="phClr">
+                <a:shade val="63000"/>
+                <a:satMod val="120000"/>
+              </a:schemeClr>
+            </a:gs>
+          </a:gsLst>
+          <a:lin ang="5400000" scaled="0"/>
+        </a:gradFill>
+      </a:bgFillStyleLst>
+    </a:fmtScheme>
+  </a:themeElements>
+  <a:objectDefaults>
+    <a:lnDef>
+      <a:spPr/>
+      <a:bodyPr/>
+      <a:lstStyle/>
+      <a:style>
+        <a:lnRef idx="2">
+          <a:schemeClr val="accent1"/>
+        </a:lnRef>
+        <a:fillRef idx="0">
+          <a:schemeClr val="accent1"/>
+        </a:fillRef>
+        <a:effectRef idx="1">
+          <a:schemeClr val="accent1"/>
+        </a:effectRef>
+        <a:fontRef idx="minor">
+          <a:schemeClr val="tx1"/>
+        </a:fontRef>
+      </a:style>
+    </a:lnDef>
+  </a:objectDefaults>
+  <a:extraClrSchemeLst/>
+  <a:extLst>
+    <a:ext uri="{05A4C25C-085E-4340-85A3-A5531E510DB2}">
+      <thm15:themeFamily xmlns:thm15="http://schemas.microsoft.com/office/thememl/2012/main" name="Office Theme" id="{2E142A2C-CD16-42D6-873A-C26D2A0506FA}" vid="{1BDDFF52-6CD6-40A5-AB3C-68EB2F1E4D0A}"/>
+    </a:ext>
+  </a:extLst>
+</a:theme>
 </file>
</xml_diff>

<commit_message>
Sync ownership to Shaked Akrish + add browser calculator and deployment configs
- Replace owner name across docs, presentation, git config, and settings
- Fix model accuracy: LR/Ridge as Best Model in all reports (sync with model_meta.json)
- Add standalone browser calculator (calculator.html) — no server required
- Configure Streamlit Community Cloud deployment (runtime.txt, .streamlit/config.toml, requirements pin)
- Add DEPLOY.md with step-by-step deployment instructions
- Improve presentation Hebrew clarity (slides 2-8)
- Sync build_pptx.js with presentation edits
- Clean up gradient_boosting_reg bug in train.py
- Update README/SKILL with Live Demo section and Python 3.12 compatibility
</commit_message>
<xml_diff>
--- a/presentation/final_presentation.pptx
+++ b/presentation/final_presentation.pptx
@@ -2487,7 +2487,7 @@
                 <a:ea typeface="Calibri" pitchFamily="34" charset="-122"/>
                 <a:cs typeface="Calibri" pitchFamily="34" charset="-120"/>
               </a:rPr>
-              <a:t>אפס</a:t>
+              <a:t>אין</a:t>
             </a:r>
             <a:endParaRPr lang="en-US" sz="3400" dirty="0"/>
           </a:p>
@@ -2543,7 +2543,7 @@
                 <a:ea typeface="Calibri" pitchFamily="34" charset="-122"/>
                 <a:cs typeface="Calibri" pitchFamily="34" charset="-120"/>
               </a:rPr>
-              <a:t>סיסטמטי</a:t>
+              <a:t>שיטתי</a:t>
             </a:r>
             <a:endParaRPr lang="en-US" sz="1200" dirty="0"/>
           </a:p>
@@ -2807,7 +2807,7 @@
                 <a:ea typeface="Calibri" pitchFamily="34" charset="-122"/>
                 <a:cs typeface="Calibri" pitchFamily="34" charset="-120"/>
               </a:rPr>
-              <a:t>משאבי תכנון יקרים מוצאים על פרויקטים שנדונים לכישלון</a:t>
+              <a:t>משאבי תכנון יקרים מבוזבזים על פרויקטים שנידונים מראש לכישלון</a:t>
             </a:r>
             <a:endParaRPr lang="en-US" sz="1400" dirty="0"/>
           </a:p>
@@ -2906,7 +2906,7 @@
                 <a:ea typeface="Calibri" pitchFamily="34" charset="-122"/>
                 <a:cs typeface="Calibri" pitchFamily="34" charset="-120"/>
               </a:rPr>
-              <a:t>הפתרון — Pipeline מלא מקצה לקצה</a:t>
+              <a:t>הפתרון — מערכת מלאה מקצה לקצה</a:t>
             </a:r>
             <a:endParaRPr lang="en-US" sz="2600" dirty="0"/>
           </a:p>
@@ -3920,7 +3920,7 @@
                 <a:ea typeface="Calibri" pitchFamily="34" charset="-122"/>
                 <a:cs typeface="Calibri" pitchFamily="34" charset="-120"/>
               </a:rPr>
-              <a:t>Auto Select</a:t>
+              <a:t>בחירה אוטומטית</a:t>
             </a:r>
             <a:endParaRPr lang="en-US" sz="1100" dirty="0"/>
           </a:p>
@@ -4360,7 +4360,7 @@
                 <a:ea typeface="Calibri" pitchFamily="34" charset="-122"/>
                 <a:cs typeface="Calibri" pitchFamily="34" charset="-120"/>
               </a:rPr>
-              <a:t>📈  ניתוח רגישות 5 תרחישים</a:t>
+              <a:t>📈  ניתוח רגישות — 6 תרחישים</a:t>
             </a:r>
             <a:endParaRPr lang="en-US" sz="1100" dirty="0"/>
           </a:p>
@@ -4401,7 +4401,7 @@
                 <a:ea typeface="Calibri" pitchFamily="34" charset="-122"/>
                 <a:cs typeface="Calibri" pitchFamily="34" charset="-120"/>
               </a:rPr>
-              <a:t>🇮🇱  ממשק עברית RTL</a:t>
+              <a:t>🇮🇱  ממשק בעברית (RTL)</a:t>
             </a:r>
             <a:endParaRPr lang="en-US" sz="1100" dirty="0"/>
           </a:p>
@@ -4869,7 +4869,7 @@
                 <a:ea typeface="Calibri" pitchFamily="34" charset="-122"/>
                 <a:cs typeface="Calibri" pitchFamily="34" charset="-120"/>
               </a:rPr>
-              <a:t>Class imbalance: 80% כדאי</a:t>
+              <a:t>חוסר איזון במחלקות — 80% כדאי</a:t>
             </a:r>
             <a:endParaRPr lang="en-US" sz="1200" dirty="0"/>
           </a:p>
@@ -5813,7 +5813,7 @@
                 <a:ea typeface="Calibri" pitchFamily="34" charset="-122"/>
                 <a:cs typeface="Calibri" pitchFamily="34" charset="-120"/>
               </a:rPr>
-              <a:t>ההנדסה שיפרה AUC בממוצע +0.04 נקודות | class_weight='balanced' לטיפול ב-imbalance</a:t>
+              <a:t>הוספת הפיצ'רים המחושבים שיפרה את ה-AUC ב-0.04 בממוצע · class_weight='balanced' לטיפול בחוסר האיזון</a:t>
             </a:r>
             <a:endParaRPr lang="en-US" sz="1100" dirty="0"/>
           </a:p>
@@ -5912,7 +5912,7 @@
                 <a:ea typeface="Calibri" pitchFamily="34" charset="-122"/>
                 <a:cs typeface="Calibri" pitchFamily="34" charset="-120"/>
               </a:rPr>
-              <a:t>תוצאות מודלים</a:t>
+              <a:t>תוצאות המודלים</a:t>
             </a:r>
             <a:endParaRPr lang="en-US" sz="2800" dirty="0"/>
           </a:p>
@@ -6935,7 +6935,7 @@
                           <a:ea typeface="Calibri" pitchFamily="34" charset="-122"/>
                           <a:cs typeface="Calibri" pitchFamily="34" charset="-120"/>
                         </a:rPr>
-                        <a:t>Logistic Reg ★</a:t>
+                        <a:t>רגרסיה לוגיסטית ★</a:t>
                       </a:r>
                       <a:endParaRPr lang="en-US" sz="1100" dirty="0">
                         <a:latin typeface="Calibri" charset="0"/>
@@ -8078,7 +8078,7 @@
                           <a:ea typeface="Calibri" pitchFamily="34" charset="-122"/>
                           <a:cs typeface="Calibri" pitchFamily="34" charset="-120"/>
                         </a:rPr>
-                        <a:t>Ridge ★</a:t>
+                        <a:t>Ridge (L2) ★</a:t>
                       </a:r>
                       <a:endParaRPr lang="en-US" sz="1100" dirty="0">
                         <a:latin typeface="Calibri" charset="0"/>
@@ -9190,7 +9190,7 @@
                 <a:ea typeface="Calibri" pitchFamily="34" charset="-122"/>
                 <a:cs typeface="Calibri" pitchFamily="34" charset="-120"/>
               </a:rPr>
-              <a:t>• sidebar קלט עם 13 פרמטרים</a:t>
+              <a:t>• סרגל צד עם 15+ פרמטרי קלט</a:t>
             </a:r>
             <a:endParaRPr lang="en-US" sz="1200" dirty="0"/>
           </a:p>
@@ -9229,7 +9229,7 @@
                 <a:ea typeface="Calibri" pitchFamily="34" charset="-122"/>
                 <a:cs typeface="Calibri" pitchFamily="34" charset="-120"/>
               </a:rPr>
-              <a:t>• ציון גדול + verdict badge</a:t>
+              <a:t>• תצוגת ציון גדולה + תג "כדאי / לא כדאי"</a:t>
             </a:r>
             <a:endParaRPr lang="en-US" sz="1200" dirty="0"/>
           </a:p>
@@ -9268,7 +9268,7 @@
                 <a:ea typeface="Calibri" pitchFamily="34" charset="-122"/>
                 <a:cs typeface="Calibri" pitchFamily="34" charset="-120"/>
               </a:rPr>
-              <a:t>• סיכום כלכלי (revenue, costs, profit)</a:t>
+              <a:t>• סיכום כלכלי (הכנסות, עלויות, רווח)</a:t>
             </a:r>
             <a:endParaRPr lang="en-US" sz="1200" dirty="0"/>
           </a:p>
@@ -9307,7 +9307,7 @@
                 <a:ea typeface="Calibri" pitchFamily="34" charset="-122"/>
                 <a:cs typeface="Calibri" pitchFamily="34" charset="-120"/>
               </a:rPr>
-              <a:t>• טבלת רגישות 5 תרחישים אוטומטיים</a:t>
+              <a:t>• טבלת רגישות — 6 תרחישים אוטומטיים</a:t>
             </a:r>
             <a:endParaRPr lang="en-US" sz="1200" dirty="0"/>
           </a:p>
@@ -10826,7 +10826,7 @@
                 <a:ea typeface="Calibri" pitchFamily="34" charset="-122"/>
                 <a:cs typeface="Calibri" pitchFamily="34" charset="-120"/>
               </a:rPr>
-              <a:t>ירוק = תורם לחיוב | אדום = תורם לשלילה | ערכים יחסיים (TreeExplainer)</a:t>
+              <a:t>ירוק = תורם לכדאיות · אדום = תורם נגד · ערכי SHAP יחסיים (LinearExplainer — מנורמלים ל-100% עבור הפיצ'ר הדומיננטי)</a:t>
             </a:r>
             <a:endParaRPr lang="en-US" sz="1000" dirty="0"/>
           </a:p>
@@ -11614,7 +11614,7 @@
                 <a:ea typeface="Calibri" pitchFamily="34" charset="-122"/>
                 <a:cs typeface="Calibri" pitchFamily="34" charset="-120"/>
               </a:rPr>
-              <a:t>כלי pre-screening אוטומטי שמסנן פרויקטים לפני הקצאת משאבי תכנון</a:t>
+              <a:t>כלי לסינון מוקדם ואוטומטי המסנן פרויקטים לפני הקצאת משאבי תכנון</a:t>
             </a:r>
             <a:endParaRPr lang="en-US" sz="1300" dirty="0"/>
           </a:p>
@@ -11680,7 +11680,7 @@
                 <a:ea typeface="Calibri" pitchFamily="34" charset="-122"/>
                 <a:cs typeface="Calibri" pitchFamily="34" charset="-120"/>
               </a:rPr>
-              <a:t>ארכיטקטורת ML pipeline מלאה ב-&lt; 600 שורות Python</a:t>
+              <a:t>ארכיטקטורת ML מלאה — פחות מ-900 שורות Python</a:t>
             </a:r>
             <a:endParaRPr lang="en-US" sz="1300" dirty="0"/>
           </a:p>
@@ -11812,7 +11812,7 @@
                 <a:ea typeface="Calibri" pitchFamily="34" charset="-122"/>
                 <a:cs typeface="Calibri" pitchFamily="34" charset="-120"/>
               </a:rPr>
-              <a:t>ממשק Streamlit בעברית עם RTL מלא ו-SHAP visual</a:t>
+              <a:t>ממשק Streamlit בעברית מלאה (RTL) עם הסברי SHAP חזותיים</a:t>
             </a:r>
             <a:endParaRPr lang="en-US" sz="1300" dirty="0"/>
           </a:p>
@@ -11917,7 +11917,7 @@
                 <a:ea typeface="Calibri" pitchFamily="34" charset="-122"/>
                 <a:cs typeface="Calibri" pitchFamily="34" charset="-120"/>
               </a:rPr>
-              <a:t>המשך מוצע: הוספת folium map · Streamlit Cloud deployment · batch CSV mode</a:t>
+              <a:t>המשך מוצע: מפת חום גיאוגרפית (folium) · עיבוד אצווה (CSV) · שילוב נתוני שוק חיים</a:t>
             </a:r>
             <a:endParaRPr lang="en-US" sz="1100" dirty="0"/>
           </a:p>

</xml_diff>